<commit_message>
Credit Mohamed Salah on the cover and closing slides
Co-Authored-By: Claude Opus 5.5 <noreply@anthropic.com>
Claude-Session: https://claude.ai/code/session_01JeVbzD2rAHCYs1K7PLWu9u
</commit_message>
<xml_diff>
--- a/starbucks-training/Starbucks_Shift_Supervisor_Program.pptx
+++ b/starbucks-training/Starbucks_Shift_Supervisor_Program.pptx
@@ -133,14 +133,14 @@
   <p:extLst>
     <p:ext uri="{521415D9-36F7-43E2-AB2F-B90AF26B5E84}">
       <p14:sectionLst xmlns:p14="http://schemas.microsoft.com/office/powerpoint/2010/main">
-        <p14:section name="Opening" id="{bc7a931f-274e-b12d-89c0-fe3a5d6ee17b}">
+        <p14:section name="Opening" id="{613f677f-4a1d-645c-31b0-424c2bf1a0c9}">
           <p14:sldIdLst>
             <p14:sldId id="256"/>
             <p14:sldId id="257"/>
             <p14:sldId id="258"/>
           </p14:sldIdLst>
         </p14:section>
-        <p14:section name="01 Transition Effectively" id="{05c9779c-d095-329c-343c-c758e41b0398}">
+        <p14:section name="01 Transition Effectively" id="{aa250ab5-044c-eade-6383-96c3deaa309e}">
           <p14:sldIdLst>
             <p14:sldId id="259"/>
             <p14:sldId id="260"/>
@@ -151,7 +151,7 @@
             <p14:sldId id="265"/>
           </p14:sldIdLst>
         </p14:section>
-        <p14:section name="02 Communicate Effectively" id="{ac5b2153-8726-6cf7-03f4-774c53538eaf}">
+        <p14:section name="02 Communicate Effectively" id="{2c8d48fc-9661-69f2-cc2f-fc449fe4e7b4}">
           <p14:sldIdLst>
             <p14:sldId id="266"/>
             <p14:sldId id="267"/>
@@ -163,7 +163,7 @@
             <p14:sldId id="273"/>
           </p14:sldIdLst>
         </p14:section>
-        <p14:section name="03 Effective Time Management" id="{c8c120ac-4f3a-e1cf-558c-d10e941d769a}">
+        <p14:section name="03 Effective Time Management" id="{add9c7d1-1b7d-7ced-9fd8-22207a1c95b7}">
           <p14:sldIdLst>
             <p14:sldId id="274"/>
             <p14:sldId id="275"/>
@@ -173,7 +173,7 @@
             <p14:sldId id="279"/>
           </p14:sldIdLst>
         </p14:section>
-        <p14:section name="Closing" id="{b10a767a-13c0-34c8-f23a-3c360627ebf0}">
+        <p14:section name="Closing" id="{760bfcb7-9b88-78e9-e46e-f326560e1521}">
           <p14:sldIdLst>
             <p14:sldId id="280"/>
             <p14:sldId id="281"/>
@@ -4267,6 +4267,42 @@
           </a:p>
         </p:txBody>
       </p:sp>
+      <p:sp>
+        <p:nvSpPr>
+          <p:cNvPr id="17" name="text-13"/>
+          <p:cNvSpPr txBox="1"/>
+          <p:nvPr/>
+        </p:nvSpPr>
+        <p:spPr>
+          <a:xfrm>
+            <a:off x="640080" y="5943600"/>
+            <a:ext cx="5760720" cy="411480"/>
+          </a:xfrm>
+          <a:prstGeom prst="rect">
+            <a:avLst/>
+          </a:prstGeom>
+          <a:noFill/>
+          <a:ln/>
+        </p:spPr>
+        <p:txBody>
+          <a:bodyPr wrap="square" lIns="0" tIns="0" rIns="0" bIns="0" rtlCol="0" anchor="ctr"/>
+          <a:lstStyle/>
+          <a:p>
+            <a:pPr indent="0" marL="0">
+              <a:buNone/>
+            </a:pPr>
+            <a:r>
+              <a:rPr lang="en-US" sz="1800" b="1" dirty="0">
+                <a:solidFill>
+                  <a:schemeClr val="accent3"/>
+                </a:solidFill>
+              </a:rPr>
+              <a:t>by Mohamed Salah</a:t>
+            </a:r>
+            <a:endParaRPr lang="en-US" sz="1800" dirty="0"/>
+          </a:p>
+        </p:txBody>
+      </p:sp>
     </p:spTree>
   </p:cSld>
   <p:clrMapOvr>
@@ -4370,7 +4406,7 @@
       </p:sp>
       <p:sp>
         <p:nvSpPr>
-          <p:cNvPr id="4" name="card-145"/>
+          <p:cNvPr id="4" name="card-146"/>
           <p:cNvSpPr/>
           <p:nvPr/>
         </p:nvSpPr>
@@ -4404,7 +4440,7 @@
       </p:sp>
       <p:sp>
         <p:nvSpPr>
-          <p:cNvPr id="5" name="text-146"/>
+          <p:cNvPr id="5" name="text-147"/>
           <p:cNvSpPr txBox="1"/>
           <p:nvPr/>
         </p:nvSpPr>
@@ -4454,7 +4490,7 @@
       </p:sp>
       <p:sp>
         <p:nvSpPr>
-          <p:cNvPr id="6" name="text-147"/>
+          <p:cNvPr id="6" name="text-148"/>
           <p:cNvSpPr txBox="1"/>
           <p:nvPr/>
         </p:nvSpPr>
@@ -4490,7 +4526,7 @@
       </p:sp>
       <p:sp>
         <p:nvSpPr>
-          <p:cNvPr id="7" name="text-148"/>
+          <p:cNvPr id="7" name="text-149"/>
           <p:cNvSpPr txBox="1"/>
           <p:nvPr/>
         </p:nvSpPr>
@@ -4608,7 +4644,7 @@
       </p:sp>
       <p:sp>
         <p:nvSpPr>
-          <p:cNvPr id="8" name="card-149"/>
+          <p:cNvPr id="8" name="card-150"/>
           <p:cNvSpPr/>
           <p:nvPr/>
         </p:nvSpPr>
@@ -4642,7 +4678,7 @@
       </p:sp>
       <p:sp>
         <p:nvSpPr>
-          <p:cNvPr id="9" name="text-150"/>
+          <p:cNvPr id="9" name="text-151"/>
           <p:cNvSpPr txBox="1"/>
           <p:nvPr/>
         </p:nvSpPr>
@@ -4692,7 +4728,7 @@
       </p:sp>
       <p:sp>
         <p:nvSpPr>
-          <p:cNvPr id="10" name="text-151"/>
+          <p:cNvPr id="10" name="text-152"/>
           <p:cNvSpPr txBox="1"/>
           <p:nvPr/>
         </p:nvSpPr>
@@ -4728,7 +4764,7 @@
       </p:sp>
       <p:sp>
         <p:nvSpPr>
-          <p:cNvPr id="11" name="text-152"/>
+          <p:cNvPr id="11" name="text-153"/>
           <p:cNvSpPr txBox="1"/>
           <p:nvPr/>
         </p:nvSpPr>
@@ -4846,7 +4882,7 @@
       </p:sp>
       <p:sp>
         <p:nvSpPr>
-          <p:cNvPr id="12" name="card-153"/>
+          <p:cNvPr id="12" name="card-154"/>
           <p:cNvSpPr/>
           <p:nvPr/>
         </p:nvSpPr>
@@ -4880,7 +4916,7 @@
       </p:sp>
       <p:sp>
         <p:nvSpPr>
-          <p:cNvPr id="13" name="text-154"/>
+          <p:cNvPr id="13" name="text-155"/>
           <p:cNvSpPr txBox="1"/>
           <p:nvPr/>
         </p:nvSpPr>
@@ -4930,7 +4966,7 @@
       </p:sp>
       <p:sp>
         <p:nvSpPr>
-          <p:cNvPr id="14" name="text-155"/>
+          <p:cNvPr id="14" name="text-156"/>
           <p:cNvSpPr txBox="1"/>
           <p:nvPr/>
         </p:nvSpPr>
@@ -4966,7 +5002,7 @@
       </p:sp>
       <p:sp>
         <p:nvSpPr>
-          <p:cNvPr id="15" name="text-156"/>
+          <p:cNvPr id="15" name="text-157"/>
           <p:cNvSpPr txBox="1"/>
           <p:nvPr/>
         </p:nvSpPr>
@@ -5548,7 +5584,7 @@
       </p:sp>
       <p:sp>
         <p:nvSpPr>
-          <p:cNvPr id="5" name="icon-bg-157"/>
+          <p:cNvPr id="5" name="icon-bg-158"/>
           <p:cNvSpPr/>
           <p:nvPr/>
         </p:nvSpPr>
@@ -5573,7 +5609,7 @@
       </p:sp>
       <p:pic>
         <p:nvPicPr>
-          <p:cNvPr id="6" name="icon-158" descr="preencoded.png">    </p:cNvPr>
+          <p:cNvPr id="6" name="icon-159" descr="preencoded.png">    </p:cNvPr>
           <p:cNvPicPr>
             <a:picLocks noChangeAspect="1"/>
           </p:cNvPicPr>
@@ -5597,7 +5633,7 @@
       </p:pic>
       <p:sp>
         <p:nvSpPr>
-          <p:cNvPr id="7" name="card-159"/>
+          <p:cNvPr id="7" name="card-160"/>
           <p:cNvSpPr/>
           <p:nvPr/>
         </p:nvSpPr>
@@ -5631,7 +5667,7 @@
       </p:sp>
       <p:sp>
         <p:nvSpPr>
-          <p:cNvPr id="8" name="text-160"/>
+          <p:cNvPr id="8" name="text-161"/>
           <p:cNvSpPr txBox="1"/>
           <p:nvPr/>
         </p:nvSpPr>
@@ -5718,7 +5754,7 @@
       </p:sp>
       <p:sp>
         <p:nvSpPr>
-          <p:cNvPr id="9" name="icon-bg-161"/>
+          <p:cNvPr id="9" name="icon-bg-162"/>
           <p:cNvSpPr/>
           <p:nvPr/>
         </p:nvSpPr>
@@ -5743,7 +5779,7 @@
       </p:sp>
       <p:pic>
         <p:nvPicPr>
-          <p:cNvPr id="10" name="icon-162" descr="preencoded.png">    </p:cNvPr>
+          <p:cNvPr id="10" name="icon-163" descr="preencoded.png">    </p:cNvPr>
           <p:cNvPicPr>
             <a:picLocks noChangeAspect="1"/>
           </p:cNvPicPr>
@@ -5767,7 +5803,7 @@
       </p:pic>
       <p:sp>
         <p:nvSpPr>
-          <p:cNvPr id="11" name="card-163"/>
+          <p:cNvPr id="11" name="card-164"/>
           <p:cNvSpPr/>
           <p:nvPr/>
         </p:nvSpPr>
@@ -5801,7 +5837,7 @@
       </p:sp>
       <p:sp>
         <p:nvSpPr>
-          <p:cNvPr id="12" name="text-164"/>
+          <p:cNvPr id="12" name="text-165"/>
           <p:cNvSpPr txBox="1"/>
           <p:nvPr/>
         </p:nvSpPr>
@@ -5888,7 +5924,7 @@
       </p:sp>
       <p:sp>
         <p:nvSpPr>
-          <p:cNvPr id="13" name="icon-bg-165"/>
+          <p:cNvPr id="13" name="icon-bg-166"/>
           <p:cNvSpPr/>
           <p:nvPr/>
         </p:nvSpPr>
@@ -5913,7 +5949,7 @@
       </p:sp>
       <p:pic>
         <p:nvPicPr>
-          <p:cNvPr id="14" name="icon-166" descr="preencoded.png">    </p:cNvPr>
+          <p:cNvPr id="14" name="icon-167" descr="preencoded.png">    </p:cNvPr>
           <p:cNvPicPr>
             <a:picLocks noChangeAspect="1"/>
           </p:cNvPicPr>
@@ -5937,7 +5973,7 @@
       </p:pic>
       <p:sp>
         <p:nvSpPr>
-          <p:cNvPr id="15" name="card-167"/>
+          <p:cNvPr id="15" name="card-168"/>
           <p:cNvSpPr/>
           <p:nvPr/>
         </p:nvSpPr>
@@ -5971,7 +6007,7 @@
       </p:sp>
       <p:sp>
         <p:nvSpPr>
-          <p:cNvPr id="16" name="text-168"/>
+          <p:cNvPr id="16" name="text-169"/>
           <p:cNvSpPr txBox="1"/>
           <p:nvPr/>
         </p:nvSpPr>
@@ -6058,7 +6094,7 @@
       </p:sp>
       <p:sp>
         <p:nvSpPr>
-          <p:cNvPr id="17" name="icon-bg-169"/>
+          <p:cNvPr id="17" name="icon-bg-170"/>
           <p:cNvSpPr/>
           <p:nvPr/>
         </p:nvSpPr>
@@ -6083,7 +6119,7 @@
       </p:sp>
       <p:pic>
         <p:nvPicPr>
-          <p:cNvPr id="18" name="icon-170" descr="preencoded.png">    </p:cNvPr>
+          <p:cNvPr id="18" name="icon-171" descr="preencoded.png">    </p:cNvPr>
           <p:cNvPicPr>
             <a:picLocks noChangeAspect="1"/>
           </p:cNvPicPr>
@@ -6107,7 +6143,7 @@
       </p:pic>
       <p:sp>
         <p:nvSpPr>
-          <p:cNvPr id="19" name="card-171"/>
+          <p:cNvPr id="19" name="card-172"/>
           <p:cNvSpPr/>
           <p:nvPr/>
         </p:nvSpPr>
@@ -6141,7 +6177,7 @@
       </p:sp>
       <p:sp>
         <p:nvSpPr>
-          <p:cNvPr id="20" name="text-172"/>
+          <p:cNvPr id="20" name="text-173"/>
           <p:cNvSpPr txBox="1"/>
           <p:nvPr/>
         </p:nvSpPr>
@@ -6228,7 +6264,7 @@
       </p:sp>
       <p:sp>
         <p:nvSpPr>
-          <p:cNvPr id="21" name="icon-bg-173"/>
+          <p:cNvPr id="21" name="icon-bg-174"/>
           <p:cNvSpPr/>
           <p:nvPr/>
         </p:nvSpPr>
@@ -6253,7 +6289,7 @@
       </p:sp>
       <p:pic>
         <p:nvPicPr>
-          <p:cNvPr id="22" name="icon-174" descr="preencoded.png">    </p:cNvPr>
+          <p:cNvPr id="22" name="icon-175" descr="preencoded.png">    </p:cNvPr>
           <p:cNvPicPr>
             <a:picLocks noChangeAspect="1"/>
           </p:cNvPicPr>
@@ -6277,7 +6313,7 @@
       </p:pic>
       <p:sp>
         <p:nvSpPr>
-          <p:cNvPr id="23" name="card-175"/>
+          <p:cNvPr id="23" name="card-176"/>
           <p:cNvSpPr/>
           <p:nvPr/>
         </p:nvSpPr>
@@ -6311,7 +6347,7 @@
       </p:sp>
       <p:sp>
         <p:nvSpPr>
-          <p:cNvPr id="24" name="text-176"/>
+          <p:cNvPr id="24" name="text-177"/>
           <p:cNvSpPr txBox="1"/>
           <p:nvPr/>
         </p:nvSpPr>
@@ -6544,7 +6580,7 @@
       </p:sp>
       <p:sp>
         <p:nvSpPr>
-          <p:cNvPr id="4" name="card-177"/>
+          <p:cNvPr id="4" name="card-178"/>
           <p:cNvSpPr/>
           <p:nvPr/>
         </p:nvSpPr>
@@ -6578,7 +6614,7 @@
       </p:sp>
       <p:sp>
         <p:nvSpPr>
-          <p:cNvPr id="5" name="step-178"/>
+          <p:cNvPr id="5" name="step-179"/>
           <p:cNvSpPr/>
           <p:nvPr/>
         </p:nvSpPr>
@@ -6603,7 +6639,7 @@
       </p:sp>
       <p:sp>
         <p:nvSpPr>
-          <p:cNvPr id="6" name="text-179"/>
+          <p:cNvPr id="6" name="text-180"/>
           <p:cNvSpPr txBox="1"/>
           <p:nvPr/>
         </p:nvSpPr>
@@ -6639,7 +6675,7 @@
       </p:sp>
       <p:sp>
         <p:nvSpPr>
-          <p:cNvPr id="7" name="text-180"/>
+          <p:cNvPr id="7" name="text-181"/>
           <p:cNvSpPr txBox="1"/>
           <p:nvPr/>
         </p:nvSpPr>
@@ -6689,7 +6725,7 @@
       </p:sp>
       <p:sp>
         <p:nvSpPr>
-          <p:cNvPr id="8" name="text-181"/>
+          <p:cNvPr id="8" name="text-182"/>
           <p:cNvSpPr txBox="1"/>
           <p:nvPr/>
         </p:nvSpPr>
@@ -6739,7 +6775,7 @@
       </p:sp>
       <p:sp>
         <p:nvSpPr>
-          <p:cNvPr id="9" name="card-182"/>
+          <p:cNvPr id="9" name="card-183"/>
           <p:cNvSpPr/>
           <p:nvPr/>
         </p:nvSpPr>
@@ -6773,7 +6809,7 @@
       </p:sp>
       <p:sp>
         <p:nvSpPr>
-          <p:cNvPr id="10" name="step-183"/>
+          <p:cNvPr id="10" name="step-184"/>
           <p:cNvSpPr/>
           <p:nvPr/>
         </p:nvSpPr>
@@ -6798,7 +6834,7 @@
       </p:sp>
       <p:sp>
         <p:nvSpPr>
-          <p:cNvPr id="11" name="text-184"/>
+          <p:cNvPr id="11" name="text-185"/>
           <p:cNvSpPr txBox="1"/>
           <p:nvPr/>
         </p:nvSpPr>
@@ -6834,7 +6870,7 @@
       </p:sp>
       <p:sp>
         <p:nvSpPr>
-          <p:cNvPr id="12" name="text-185"/>
+          <p:cNvPr id="12" name="text-186"/>
           <p:cNvSpPr txBox="1"/>
           <p:nvPr/>
         </p:nvSpPr>
@@ -6884,7 +6920,7 @@
       </p:sp>
       <p:sp>
         <p:nvSpPr>
-          <p:cNvPr id="13" name="text-186"/>
+          <p:cNvPr id="13" name="text-187"/>
           <p:cNvSpPr txBox="1"/>
           <p:nvPr/>
         </p:nvSpPr>
@@ -6934,7 +6970,7 @@
       </p:sp>
       <p:sp>
         <p:nvSpPr>
-          <p:cNvPr id="14" name="card-187"/>
+          <p:cNvPr id="14" name="card-188"/>
           <p:cNvSpPr/>
           <p:nvPr/>
         </p:nvSpPr>
@@ -6968,7 +7004,7 @@
       </p:sp>
       <p:sp>
         <p:nvSpPr>
-          <p:cNvPr id="15" name="step-188"/>
+          <p:cNvPr id="15" name="step-189"/>
           <p:cNvSpPr/>
           <p:nvPr/>
         </p:nvSpPr>
@@ -6993,7 +7029,7 @@
       </p:sp>
       <p:sp>
         <p:nvSpPr>
-          <p:cNvPr id="16" name="text-189"/>
+          <p:cNvPr id="16" name="text-190"/>
           <p:cNvSpPr txBox="1"/>
           <p:nvPr/>
         </p:nvSpPr>
@@ -7029,7 +7065,7 @@
       </p:sp>
       <p:sp>
         <p:nvSpPr>
-          <p:cNvPr id="17" name="text-190"/>
+          <p:cNvPr id="17" name="text-191"/>
           <p:cNvSpPr txBox="1"/>
           <p:nvPr/>
         </p:nvSpPr>
@@ -7079,7 +7115,7 @@
       </p:sp>
       <p:sp>
         <p:nvSpPr>
-          <p:cNvPr id="18" name="text-191"/>
+          <p:cNvPr id="18" name="text-192"/>
           <p:cNvSpPr txBox="1"/>
           <p:nvPr/>
         </p:nvSpPr>
@@ -7129,7 +7165,7 @@
       </p:sp>
       <p:sp>
         <p:nvSpPr>
-          <p:cNvPr id="19" name="card-192"/>
+          <p:cNvPr id="19" name="card-193"/>
           <p:cNvSpPr/>
           <p:nvPr/>
         </p:nvSpPr>
@@ -7163,7 +7199,7 @@
       </p:sp>
       <p:sp>
         <p:nvSpPr>
-          <p:cNvPr id="20" name="step-193"/>
+          <p:cNvPr id="20" name="step-194"/>
           <p:cNvSpPr/>
           <p:nvPr/>
         </p:nvSpPr>
@@ -7188,7 +7224,7 @@
       </p:sp>
       <p:sp>
         <p:nvSpPr>
-          <p:cNvPr id="21" name="text-194"/>
+          <p:cNvPr id="21" name="text-195"/>
           <p:cNvSpPr txBox="1"/>
           <p:nvPr/>
         </p:nvSpPr>
@@ -7224,7 +7260,7 @@
       </p:sp>
       <p:sp>
         <p:nvSpPr>
-          <p:cNvPr id="22" name="text-195"/>
+          <p:cNvPr id="22" name="text-196"/>
           <p:cNvSpPr txBox="1"/>
           <p:nvPr/>
         </p:nvSpPr>
@@ -7274,7 +7310,7 @@
       </p:sp>
       <p:sp>
         <p:nvSpPr>
-          <p:cNvPr id="23" name="text-196"/>
+          <p:cNvPr id="23" name="text-197"/>
           <p:cNvSpPr txBox="1"/>
           <p:nvPr/>
         </p:nvSpPr>
@@ -7324,7 +7360,7 @@
       </p:sp>
       <p:sp>
         <p:nvSpPr>
-          <p:cNvPr id="24" name="card-197"/>
+          <p:cNvPr id="24" name="card-198"/>
           <p:cNvSpPr/>
           <p:nvPr/>
         </p:nvSpPr>
@@ -7358,7 +7394,7 @@
       </p:sp>
       <p:sp>
         <p:nvSpPr>
-          <p:cNvPr id="25" name="icon-bg-198"/>
+          <p:cNvPr id="25" name="icon-bg-199"/>
           <p:cNvSpPr/>
           <p:nvPr/>
         </p:nvSpPr>
@@ -7383,7 +7419,7 @@
       </p:sp>
       <p:pic>
         <p:nvPicPr>
-          <p:cNvPr id="26" name="icon-199" descr="preencoded.png">    </p:cNvPr>
+          <p:cNvPr id="26" name="icon-200" descr="preencoded.png">    </p:cNvPr>
           <p:cNvPicPr>
             <a:picLocks noChangeAspect="1"/>
           </p:cNvPicPr>
@@ -7407,7 +7443,7 @@
       </p:pic>
       <p:sp>
         <p:nvSpPr>
-          <p:cNvPr id="27" name="text-200"/>
+          <p:cNvPr id="27" name="text-201"/>
           <p:cNvSpPr txBox="1"/>
           <p:nvPr/>
         </p:nvSpPr>
@@ -7654,7 +7690,7 @@
       </p:sp>
       <p:sp>
         <p:nvSpPr>
-          <p:cNvPr id="4" name="card-201"/>
+          <p:cNvPr id="4" name="card-202"/>
           <p:cNvSpPr/>
           <p:nvPr/>
         </p:nvSpPr>
@@ -7688,7 +7724,7 @@
       </p:sp>
       <p:sp>
         <p:nvSpPr>
-          <p:cNvPr id="5" name="icon-bg-202"/>
+          <p:cNvPr id="5" name="icon-bg-203"/>
           <p:cNvSpPr/>
           <p:nvPr/>
         </p:nvSpPr>
@@ -7713,7 +7749,7 @@
       </p:sp>
       <p:pic>
         <p:nvPicPr>
-          <p:cNvPr id="6" name="icon-203" descr="preencoded.png">    </p:cNvPr>
+          <p:cNvPr id="6" name="icon-204" descr="preencoded.png">    </p:cNvPr>
           <p:cNvPicPr>
             <a:picLocks noChangeAspect="1"/>
           </p:cNvPicPr>
@@ -7737,7 +7773,7 @@
       </p:pic>
       <p:sp>
         <p:nvSpPr>
-          <p:cNvPr id="7" name="text-204"/>
+          <p:cNvPr id="7" name="text-205"/>
           <p:cNvSpPr txBox="1"/>
           <p:nvPr/>
         </p:nvSpPr>
@@ -7824,7 +7860,7 @@
       </p:sp>
       <p:sp>
         <p:nvSpPr>
-          <p:cNvPr id="8" name="card-205"/>
+          <p:cNvPr id="8" name="card-206"/>
           <p:cNvSpPr/>
           <p:nvPr/>
         </p:nvSpPr>
@@ -7858,7 +7894,7 @@
       </p:sp>
       <p:sp>
         <p:nvSpPr>
-          <p:cNvPr id="9" name="icon-bg-206"/>
+          <p:cNvPr id="9" name="icon-bg-207"/>
           <p:cNvSpPr/>
           <p:nvPr/>
         </p:nvSpPr>
@@ -7883,7 +7919,7 @@
       </p:sp>
       <p:pic>
         <p:nvPicPr>
-          <p:cNvPr id="10" name="icon-207" descr="preencoded.png">    </p:cNvPr>
+          <p:cNvPr id="10" name="icon-208" descr="preencoded.png">    </p:cNvPr>
           <p:cNvPicPr>
             <a:picLocks noChangeAspect="1"/>
           </p:cNvPicPr>
@@ -7907,7 +7943,7 @@
       </p:pic>
       <p:sp>
         <p:nvSpPr>
-          <p:cNvPr id="11" name="text-208"/>
+          <p:cNvPr id="11" name="text-209"/>
           <p:cNvSpPr txBox="1"/>
           <p:nvPr/>
         </p:nvSpPr>
@@ -7994,7 +8030,7 @@
       </p:sp>
       <p:sp>
         <p:nvSpPr>
-          <p:cNvPr id="12" name="card-209"/>
+          <p:cNvPr id="12" name="card-210"/>
           <p:cNvSpPr/>
           <p:nvPr/>
         </p:nvSpPr>
@@ -8028,7 +8064,7 @@
       </p:sp>
       <p:sp>
         <p:nvSpPr>
-          <p:cNvPr id="13" name="icon-bg-210"/>
+          <p:cNvPr id="13" name="icon-bg-211"/>
           <p:cNvSpPr/>
           <p:nvPr/>
         </p:nvSpPr>
@@ -8053,7 +8089,7 @@
       </p:sp>
       <p:pic>
         <p:nvPicPr>
-          <p:cNvPr id="14" name="icon-211" descr="preencoded.png">    </p:cNvPr>
+          <p:cNvPr id="14" name="icon-212" descr="preencoded.png">    </p:cNvPr>
           <p:cNvPicPr>
             <a:picLocks noChangeAspect="1"/>
           </p:cNvPicPr>
@@ -8077,7 +8113,7 @@
       </p:pic>
       <p:sp>
         <p:nvSpPr>
-          <p:cNvPr id="15" name="text-212"/>
+          <p:cNvPr id="15" name="text-213"/>
           <p:cNvSpPr txBox="1"/>
           <p:nvPr/>
         </p:nvSpPr>
@@ -8164,7 +8200,7 @@
       </p:sp>
       <p:sp>
         <p:nvSpPr>
-          <p:cNvPr id="16" name="card-213"/>
+          <p:cNvPr id="16" name="card-214"/>
           <p:cNvSpPr/>
           <p:nvPr/>
         </p:nvSpPr>
@@ -8198,7 +8234,7 @@
       </p:sp>
       <p:sp>
         <p:nvSpPr>
-          <p:cNvPr id="17" name="icon-bg-214"/>
+          <p:cNvPr id="17" name="icon-bg-215"/>
           <p:cNvSpPr/>
           <p:nvPr/>
         </p:nvSpPr>
@@ -8223,7 +8259,7 @@
       </p:sp>
       <p:pic>
         <p:nvPicPr>
-          <p:cNvPr id="18" name="icon-215" descr="preencoded.png">    </p:cNvPr>
+          <p:cNvPr id="18" name="icon-216" descr="preencoded.png">    </p:cNvPr>
           <p:cNvPicPr>
             <a:picLocks noChangeAspect="1"/>
           </p:cNvPicPr>
@@ -8247,7 +8283,7 @@
       </p:pic>
       <p:sp>
         <p:nvSpPr>
-          <p:cNvPr id="19" name="text-216"/>
+          <p:cNvPr id="19" name="text-217"/>
           <p:cNvSpPr txBox="1"/>
           <p:nvPr/>
         </p:nvSpPr>
@@ -8334,7 +8370,7 @@
       </p:sp>
       <p:sp>
         <p:nvSpPr>
-          <p:cNvPr id="20" name="card-217"/>
+          <p:cNvPr id="20" name="card-218"/>
           <p:cNvSpPr/>
           <p:nvPr/>
         </p:nvSpPr>
@@ -8368,7 +8404,7 @@
       </p:sp>
       <p:sp>
         <p:nvSpPr>
-          <p:cNvPr id="21" name="icon-bg-218"/>
+          <p:cNvPr id="21" name="icon-bg-219"/>
           <p:cNvSpPr/>
           <p:nvPr/>
         </p:nvSpPr>
@@ -8393,7 +8429,7 @@
       </p:sp>
       <p:pic>
         <p:nvPicPr>
-          <p:cNvPr id="22" name="icon-219" descr="preencoded.png">    </p:cNvPr>
+          <p:cNvPr id="22" name="icon-220" descr="preencoded.png">    </p:cNvPr>
           <p:cNvPicPr>
             <a:picLocks noChangeAspect="1"/>
           </p:cNvPicPr>
@@ -8417,7 +8453,7 @@
       </p:pic>
       <p:sp>
         <p:nvSpPr>
-          <p:cNvPr id="23" name="text-220"/>
+          <p:cNvPr id="23" name="text-221"/>
           <p:cNvSpPr txBox="1"/>
           <p:nvPr/>
         </p:nvSpPr>
@@ -8531,7 +8567,7 @@
       </p:sp>
       <p:sp>
         <p:nvSpPr>
-          <p:cNvPr id="25" name="icon-bg-221"/>
+          <p:cNvPr id="25" name="icon-bg-222"/>
           <p:cNvSpPr/>
           <p:nvPr/>
         </p:nvSpPr>
@@ -8556,7 +8592,7 @@
       </p:sp>
       <p:pic>
         <p:nvPicPr>
-          <p:cNvPr id="26" name="icon-222" descr="preencoded.png">    </p:cNvPr>
+          <p:cNvPr id="26" name="icon-223" descr="preencoded.png">    </p:cNvPr>
           <p:cNvPicPr>
             <a:picLocks noChangeAspect="1"/>
           </p:cNvPicPr>
@@ -8580,7 +8616,7 @@
       </p:pic>
       <p:sp>
         <p:nvSpPr>
-          <p:cNvPr id="27" name="text-223"/>
+          <p:cNvPr id="27" name="text-224"/>
           <p:cNvSpPr txBox="1"/>
           <p:nvPr/>
         </p:nvSpPr>
@@ -8616,7 +8652,7 @@
       </p:sp>
       <p:sp>
         <p:nvSpPr>
-          <p:cNvPr id="28" name="text-224"/>
+          <p:cNvPr id="28" name="text-225"/>
           <p:cNvSpPr txBox="1"/>
           <p:nvPr/>
         </p:nvSpPr>
@@ -8798,7 +8834,7 @@
       </p:sp>
       <p:sp>
         <p:nvSpPr>
-          <p:cNvPr id="4" name="latte-letter-225"/>
+          <p:cNvPr id="4" name="latte-letter-226"/>
           <p:cNvSpPr/>
           <p:nvPr/>
         </p:nvSpPr>
@@ -8825,7 +8861,7 @@
       </p:sp>
       <p:sp>
         <p:nvSpPr>
-          <p:cNvPr id="5" name="text-226"/>
+          <p:cNvPr id="5" name="text-227"/>
           <p:cNvSpPr txBox="1"/>
           <p:nvPr/>
         </p:nvSpPr>
@@ -8861,7 +8897,7 @@
       </p:sp>
       <p:sp>
         <p:nvSpPr>
-          <p:cNvPr id="6" name="card-227"/>
+          <p:cNvPr id="6" name="card-228"/>
           <p:cNvSpPr/>
           <p:nvPr/>
         </p:nvSpPr>
@@ -8895,7 +8931,7 @@
       </p:sp>
       <p:sp>
         <p:nvSpPr>
-          <p:cNvPr id="7" name="text-228"/>
+          <p:cNvPr id="7" name="text-229"/>
           <p:cNvSpPr txBox="1"/>
           <p:nvPr/>
         </p:nvSpPr>
@@ -8982,7 +9018,7 @@
       </p:sp>
       <p:sp>
         <p:nvSpPr>
-          <p:cNvPr id="8" name="latte-letter-229"/>
+          <p:cNvPr id="8" name="latte-letter-230"/>
           <p:cNvSpPr/>
           <p:nvPr/>
         </p:nvSpPr>
@@ -9009,7 +9045,7 @@
       </p:sp>
       <p:sp>
         <p:nvSpPr>
-          <p:cNvPr id="9" name="text-230"/>
+          <p:cNvPr id="9" name="text-231"/>
           <p:cNvSpPr txBox="1"/>
           <p:nvPr/>
         </p:nvSpPr>
@@ -9045,7 +9081,7 @@
       </p:sp>
       <p:sp>
         <p:nvSpPr>
-          <p:cNvPr id="10" name="card-231"/>
+          <p:cNvPr id="10" name="card-232"/>
           <p:cNvSpPr/>
           <p:nvPr/>
         </p:nvSpPr>
@@ -9079,7 +9115,7 @@
       </p:sp>
       <p:sp>
         <p:nvSpPr>
-          <p:cNvPr id="11" name="text-232"/>
+          <p:cNvPr id="11" name="text-233"/>
           <p:cNvSpPr txBox="1"/>
           <p:nvPr/>
         </p:nvSpPr>
@@ -9166,7 +9202,7 @@
       </p:sp>
       <p:sp>
         <p:nvSpPr>
-          <p:cNvPr id="12" name="latte-letter-233"/>
+          <p:cNvPr id="12" name="latte-letter-234"/>
           <p:cNvSpPr/>
           <p:nvPr/>
         </p:nvSpPr>
@@ -9193,7 +9229,7 @@
       </p:sp>
       <p:sp>
         <p:nvSpPr>
-          <p:cNvPr id="13" name="text-234"/>
+          <p:cNvPr id="13" name="text-235"/>
           <p:cNvSpPr txBox="1"/>
           <p:nvPr/>
         </p:nvSpPr>
@@ -9229,7 +9265,7 @@
       </p:sp>
       <p:sp>
         <p:nvSpPr>
-          <p:cNvPr id="14" name="card-235"/>
+          <p:cNvPr id="14" name="card-236"/>
           <p:cNvSpPr/>
           <p:nvPr/>
         </p:nvSpPr>
@@ -9263,7 +9299,7 @@
       </p:sp>
       <p:sp>
         <p:nvSpPr>
-          <p:cNvPr id="15" name="text-236"/>
+          <p:cNvPr id="15" name="text-237"/>
           <p:cNvSpPr txBox="1"/>
           <p:nvPr/>
         </p:nvSpPr>
@@ -9350,7 +9386,7 @@
       </p:sp>
       <p:sp>
         <p:nvSpPr>
-          <p:cNvPr id="16" name="latte-letter-237"/>
+          <p:cNvPr id="16" name="latte-letter-238"/>
           <p:cNvSpPr/>
           <p:nvPr/>
         </p:nvSpPr>
@@ -9377,7 +9413,7 @@
       </p:sp>
       <p:sp>
         <p:nvSpPr>
-          <p:cNvPr id="17" name="text-238"/>
+          <p:cNvPr id="17" name="text-239"/>
           <p:cNvSpPr txBox="1"/>
           <p:nvPr/>
         </p:nvSpPr>
@@ -9413,7 +9449,7 @@
       </p:sp>
       <p:sp>
         <p:nvSpPr>
-          <p:cNvPr id="18" name="card-239"/>
+          <p:cNvPr id="18" name="card-240"/>
           <p:cNvSpPr/>
           <p:nvPr/>
         </p:nvSpPr>
@@ -9447,7 +9483,7 @@
       </p:sp>
       <p:sp>
         <p:nvSpPr>
-          <p:cNvPr id="19" name="text-240"/>
+          <p:cNvPr id="19" name="text-241"/>
           <p:cNvSpPr txBox="1"/>
           <p:nvPr/>
         </p:nvSpPr>
@@ -9534,7 +9570,7 @@
       </p:sp>
       <p:sp>
         <p:nvSpPr>
-          <p:cNvPr id="20" name="latte-letter-241"/>
+          <p:cNvPr id="20" name="latte-letter-242"/>
           <p:cNvSpPr/>
           <p:nvPr/>
         </p:nvSpPr>
@@ -9561,7 +9597,7 @@
       </p:sp>
       <p:sp>
         <p:nvSpPr>
-          <p:cNvPr id="21" name="text-242"/>
+          <p:cNvPr id="21" name="text-243"/>
           <p:cNvSpPr txBox="1"/>
           <p:nvPr/>
         </p:nvSpPr>
@@ -9597,7 +9633,7 @@
       </p:sp>
       <p:sp>
         <p:nvSpPr>
-          <p:cNvPr id="22" name="card-243"/>
+          <p:cNvPr id="22" name="card-244"/>
           <p:cNvSpPr/>
           <p:nvPr/>
         </p:nvSpPr>
@@ -9631,7 +9667,7 @@
       </p:sp>
       <p:sp>
         <p:nvSpPr>
-          <p:cNvPr id="23" name="text-244"/>
+          <p:cNvPr id="23" name="text-245"/>
           <p:cNvSpPr txBox="1"/>
           <p:nvPr/>
         </p:nvSpPr>
@@ -9718,7 +9754,7 @@
       </p:sp>
       <p:sp>
         <p:nvSpPr>
-          <p:cNvPr id="24" name="card-245"/>
+          <p:cNvPr id="24" name="card-246"/>
           <p:cNvSpPr/>
           <p:nvPr/>
         </p:nvSpPr>
@@ -9776,7 +9812,7 @@
       </p:pic>
       <p:sp>
         <p:nvSpPr>
-          <p:cNvPr id="26" name="text-246"/>
+          <p:cNvPr id="26" name="text-247"/>
           <p:cNvSpPr txBox="1"/>
           <p:nvPr/>
         </p:nvSpPr>
@@ -9812,7 +9848,7 @@
       </p:sp>
       <p:sp>
         <p:nvSpPr>
-          <p:cNvPr id="27" name="text-247"/>
+          <p:cNvPr id="27" name="text-248"/>
           <p:cNvSpPr txBox="1"/>
           <p:nvPr/>
         </p:nvSpPr>
@@ -9994,7 +10030,7 @@
       </p:sp>
       <p:sp>
         <p:nvSpPr>
-          <p:cNvPr id="4" name="card-248"/>
+          <p:cNvPr id="4" name="card-249"/>
           <p:cNvSpPr/>
           <p:nvPr/>
         </p:nvSpPr>
@@ -10028,7 +10064,7 @@
       </p:sp>
       <p:sp>
         <p:nvSpPr>
-          <p:cNvPr id="5" name="icon-bg-249"/>
+          <p:cNvPr id="5" name="icon-bg-250"/>
           <p:cNvSpPr/>
           <p:nvPr/>
         </p:nvSpPr>
@@ -10053,7 +10089,7 @@
       </p:sp>
       <p:pic>
         <p:nvPicPr>
-          <p:cNvPr id="6" name="icon-250" descr="preencoded.png">    </p:cNvPr>
+          <p:cNvPr id="6" name="icon-251" descr="preencoded.png">    </p:cNvPr>
           <p:cNvPicPr>
             <a:picLocks noChangeAspect="1"/>
           </p:cNvPicPr>
@@ -10077,7 +10113,7 @@
       </p:pic>
       <p:sp>
         <p:nvSpPr>
-          <p:cNvPr id="7" name="text-251"/>
+          <p:cNvPr id="7" name="text-252"/>
           <p:cNvSpPr txBox="1"/>
           <p:nvPr/>
         </p:nvSpPr>
@@ -10164,7 +10200,7 @@
       </p:sp>
       <p:sp>
         <p:nvSpPr>
-          <p:cNvPr id="8" name="card-252"/>
+          <p:cNvPr id="8" name="card-253"/>
           <p:cNvSpPr/>
           <p:nvPr/>
         </p:nvSpPr>
@@ -10198,7 +10234,7 @@
       </p:sp>
       <p:sp>
         <p:nvSpPr>
-          <p:cNvPr id="9" name="icon-bg-253"/>
+          <p:cNvPr id="9" name="icon-bg-254"/>
           <p:cNvSpPr/>
           <p:nvPr/>
         </p:nvSpPr>
@@ -10223,7 +10259,7 @@
       </p:sp>
       <p:pic>
         <p:nvPicPr>
-          <p:cNvPr id="10" name="icon-254" descr="preencoded.png">    </p:cNvPr>
+          <p:cNvPr id="10" name="icon-255" descr="preencoded.png">    </p:cNvPr>
           <p:cNvPicPr>
             <a:picLocks noChangeAspect="1"/>
           </p:cNvPicPr>
@@ -10247,7 +10283,7 @@
       </p:pic>
       <p:sp>
         <p:nvSpPr>
-          <p:cNvPr id="11" name="text-255"/>
+          <p:cNvPr id="11" name="text-256"/>
           <p:cNvSpPr txBox="1"/>
           <p:nvPr/>
         </p:nvSpPr>
@@ -10334,7 +10370,7 @@
       </p:sp>
       <p:sp>
         <p:nvSpPr>
-          <p:cNvPr id="12" name="card-256"/>
+          <p:cNvPr id="12" name="card-257"/>
           <p:cNvSpPr/>
           <p:nvPr/>
         </p:nvSpPr>
@@ -10368,7 +10404,7 @@
       </p:sp>
       <p:sp>
         <p:nvSpPr>
-          <p:cNvPr id="13" name="icon-bg-257"/>
+          <p:cNvPr id="13" name="icon-bg-258"/>
           <p:cNvSpPr/>
           <p:nvPr/>
         </p:nvSpPr>
@@ -10393,7 +10429,7 @@
       </p:sp>
       <p:pic>
         <p:nvPicPr>
-          <p:cNvPr id="14" name="icon-258" descr="preencoded.png">    </p:cNvPr>
+          <p:cNvPr id="14" name="icon-259" descr="preencoded.png">    </p:cNvPr>
           <p:cNvPicPr>
             <a:picLocks noChangeAspect="1"/>
           </p:cNvPicPr>
@@ -10417,7 +10453,7 @@
       </p:pic>
       <p:sp>
         <p:nvSpPr>
-          <p:cNvPr id="15" name="text-259"/>
+          <p:cNvPr id="15" name="text-260"/>
           <p:cNvSpPr txBox="1"/>
           <p:nvPr/>
         </p:nvSpPr>
@@ -10504,7 +10540,7 @@
       </p:sp>
       <p:sp>
         <p:nvSpPr>
-          <p:cNvPr id="16" name="card-260"/>
+          <p:cNvPr id="16" name="card-261"/>
           <p:cNvSpPr/>
           <p:nvPr/>
         </p:nvSpPr>
@@ -10538,7 +10574,7 @@
       </p:sp>
       <p:sp>
         <p:nvSpPr>
-          <p:cNvPr id="17" name="icon-bg-261"/>
+          <p:cNvPr id="17" name="icon-bg-262"/>
           <p:cNvSpPr/>
           <p:nvPr/>
         </p:nvSpPr>
@@ -10563,7 +10599,7 @@
       </p:sp>
       <p:pic>
         <p:nvPicPr>
-          <p:cNvPr id="18" name="icon-262" descr="preencoded.png">    </p:cNvPr>
+          <p:cNvPr id="18" name="icon-263" descr="preencoded.png">    </p:cNvPr>
           <p:cNvPicPr>
             <a:picLocks noChangeAspect="1"/>
           </p:cNvPicPr>
@@ -10587,7 +10623,7 @@
       </p:pic>
       <p:sp>
         <p:nvSpPr>
-          <p:cNvPr id="19" name="text-263"/>
+          <p:cNvPr id="19" name="text-264"/>
           <p:cNvSpPr txBox="1"/>
           <p:nvPr/>
         </p:nvSpPr>
@@ -10674,7 +10710,7 @@
       </p:sp>
       <p:sp>
         <p:nvSpPr>
-          <p:cNvPr id="20" name="card-264"/>
+          <p:cNvPr id="20" name="card-265"/>
           <p:cNvSpPr/>
           <p:nvPr/>
         </p:nvSpPr>
@@ -10708,7 +10744,7 @@
       </p:sp>
       <p:sp>
         <p:nvSpPr>
-          <p:cNvPr id="21" name="icon-bg-265"/>
+          <p:cNvPr id="21" name="icon-bg-266"/>
           <p:cNvSpPr/>
           <p:nvPr/>
         </p:nvSpPr>
@@ -10733,7 +10769,7 @@
       </p:sp>
       <p:pic>
         <p:nvPicPr>
-          <p:cNvPr id="22" name="icon-266" descr="preencoded.png">    </p:cNvPr>
+          <p:cNvPr id="22" name="icon-267" descr="preencoded.png">    </p:cNvPr>
           <p:cNvPicPr>
             <a:picLocks noChangeAspect="1"/>
           </p:cNvPicPr>
@@ -10757,7 +10793,7 @@
       </p:pic>
       <p:sp>
         <p:nvSpPr>
-          <p:cNvPr id="23" name="text-267"/>
+          <p:cNvPr id="23" name="text-268"/>
           <p:cNvSpPr txBox="1"/>
           <p:nvPr/>
         </p:nvSpPr>
@@ -10844,7 +10880,7 @@
       </p:sp>
       <p:sp>
         <p:nvSpPr>
-          <p:cNvPr id="24" name="card-268"/>
+          <p:cNvPr id="24" name="card-269"/>
           <p:cNvSpPr/>
           <p:nvPr/>
         </p:nvSpPr>
@@ -10878,7 +10914,7 @@
       </p:sp>
       <p:sp>
         <p:nvSpPr>
-          <p:cNvPr id="25" name="text-269"/>
+          <p:cNvPr id="25" name="text-270"/>
           <p:cNvSpPr txBox="1"/>
           <p:nvPr/>
         </p:nvSpPr>
@@ -10931,7 +10967,7 @@
       </p:sp>
       <p:sp>
         <p:nvSpPr>
-          <p:cNvPr id="26" name="text-270"/>
+          <p:cNvPr id="26" name="text-271"/>
           <p:cNvSpPr txBox="1"/>
           <p:nvPr/>
         </p:nvSpPr>
@@ -11130,7 +11166,7 @@
       </p:sp>
       <p:sp>
         <p:nvSpPr>
-          <p:cNvPr id="4" name="sbi-271"/>
+          <p:cNvPr id="4" name="sbi-272"/>
           <p:cNvSpPr/>
           <p:nvPr/>
         </p:nvSpPr>
@@ -11157,7 +11193,7 @@
       </p:sp>
       <p:sp>
         <p:nvSpPr>
-          <p:cNvPr id="5" name="text-272"/>
+          <p:cNvPr id="5" name="text-273"/>
           <p:cNvSpPr txBox="1"/>
           <p:nvPr/>
         </p:nvSpPr>
@@ -11193,7 +11229,7 @@
       </p:sp>
       <p:sp>
         <p:nvSpPr>
-          <p:cNvPr id="6" name="text-273"/>
+          <p:cNvPr id="6" name="text-274"/>
           <p:cNvSpPr txBox="1"/>
           <p:nvPr/>
         </p:nvSpPr>
@@ -11243,7 +11279,7 @@
       </p:sp>
       <p:sp>
         <p:nvSpPr>
-          <p:cNvPr id="7" name="sbi-274"/>
+          <p:cNvPr id="7" name="sbi-275"/>
           <p:cNvSpPr/>
           <p:nvPr/>
         </p:nvSpPr>
@@ -11270,7 +11306,7 @@
       </p:sp>
       <p:sp>
         <p:nvSpPr>
-          <p:cNvPr id="8" name="text-275"/>
+          <p:cNvPr id="8" name="text-276"/>
           <p:cNvSpPr txBox="1"/>
           <p:nvPr/>
         </p:nvSpPr>
@@ -11306,7 +11342,7 @@
       </p:sp>
       <p:sp>
         <p:nvSpPr>
-          <p:cNvPr id="9" name="text-276"/>
+          <p:cNvPr id="9" name="text-277"/>
           <p:cNvSpPr txBox="1"/>
           <p:nvPr/>
         </p:nvSpPr>
@@ -11356,7 +11392,7 @@
       </p:sp>
       <p:sp>
         <p:nvSpPr>
-          <p:cNvPr id="10" name="sbi-277"/>
+          <p:cNvPr id="10" name="sbi-278"/>
           <p:cNvSpPr/>
           <p:nvPr/>
         </p:nvSpPr>
@@ -11383,7 +11419,7 @@
       </p:sp>
       <p:sp>
         <p:nvSpPr>
-          <p:cNvPr id="11" name="text-278"/>
+          <p:cNvPr id="11" name="text-279"/>
           <p:cNvSpPr txBox="1"/>
           <p:nvPr/>
         </p:nvSpPr>
@@ -11419,7 +11455,7 @@
       </p:sp>
       <p:sp>
         <p:nvSpPr>
-          <p:cNvPr id="12" name="text-279"/>
+          <p:cNvPr id="12" name="text-280"/>
           <p:cNvSpPr txBox="1"/>
           <p:nvPr/>
         </p:nvSpPr>
@@ -11469,7 +11505,7 @@
       </p:sp>
       <p:sp>
         <p:nvSpPr>
-          <p:cNvPr id="13" name="sbi-280"/>
+          <p:cNvPr id="13" name="sbi-281"/>
           <p:cNvSpPr/>
           <p:nvPr/>
         </p:nvSpPr>
@@ -11496,7 +11532,7 @@
       </p:sp>
       <p:sp>
         <p:nvSpPr>
-          <p:cNvPr id="14" name="text-281"/>
+          <p:cNvPr id="14" name="text-282"/>
           <p:cNvSpPr txBox="1"/>
           <p:nvPr/>
         </p:nvSpPr>
@@ -11532,7 +11568,7 @@
       </p:sp>
       <p:sp>
         <p:nvSpPr>
-          <p:cNvPr id="15" name="text-282"/>
+          <p:cNvPr id="15" name="text-283"/>
           <p:cNvSpPr txBox="1"/>
           <p:nvPr/>
         </p:nvSpPr>
@@ -11582,7 +11618,7 @@
       </p:sp>
       <p:sp>
         <p:nvSpPr>
-          <p:cNvPr id="16" name="card-283"/>
+          <p:cNvPr id="16" name="card-284"/>
           <p:cNvSpPr/>
           <p:nvPr/>
         </p:nvSpPr>
@@ -11616,7 +11652,7 @@
       </p:sp>
       <p:sp>
         <p:nvSpPr>
-          <p:cNvPr id="17" name="text-284"/>
+          <p:cNvPr id="17" name="text-285"/>
           <p:cNvSpPr txBox="1"/>
           <p:nvPr/>
         </p:nvSpPr>
@@ -11686,7 +11722,7 @@
       </p:sp>
       <p:sp>
         <p:nvSpPr>
-          <p:cNvPr id="18" name="card-285"/>
+          <p:cNvPr id="18" name="card-286"/>
           <p:cNvSpPr/>
           <p:nvPr/>
         </p:nvSpPr>
@@ -11720,7 +11756,7 @@
       </p:sp>
       <p:sp>
         <p:nvSpPr>
-          <p:cNvPr id="19" name="text-286"/>
+          <p:cNvPr id="19" name="text-287"/>
           <p:cNvSpPr txBox="1"/>
           <p:nvPr/>
         </p:nvSpPr>
@@ -11919,7 +11955,7 @@
       </p:sp>
       <p:sp>
         <p:nvSpPr>
-          <p:cNvPr id="4" name="card-287"/>
+          <p:cNvPr id="4" name="card-288"/>
           <p:cNvSpPr/>
           <p:nvPr/>
         </p:nvSpPr>
@@ -11953,7 +11989,7 @@
       </p:sp>
       <p:sp>
         <p:nvSpPr>
-          <p:cNvPr id="5" name="icon-bg-288"/>
+          <p:cNvPr id="5" name="icon-bg-289"/>
           <p:cNvSpPr/>
           <p:nvPr/>
         </p:nvSpPr>
@@ -11978,7 +12014,7 @@
       </p:sp>
       <p:pic>
         <p:nvPicPr>
-          <p:cNvPr id="6" name="icon-289" descr="preencoded.png">    </p:cNvPr>
+          <p:cNvPr id="6" name="icon-290" descr="preencoded.png">    </p:cNvPr>
           <p:cNvPicPr>
             <a:picLocks noChangeAspect="1"/>
           </p:cNvPicPr>
@@ -12002,7 +12038,7 @@
       </p:pic>
       <p:sp>
         <p:nvSpPr>
-          <p:cNvPr id="7" name="text-290"/>
+          <p:cNvPr id="7" name="text-291"/>
           <p:cNvSpPr txBox="1"/>
           <p:nvPr/>
         </p:nvSpPr>
@@ -12052,7 +12088,7 @@
       </p:sp>
       <p:sp>
         <p:nvSpPr>
-          <p:cNvPr id="8" name="text-291"/>
+          <p:cNvPr id="8" name="text-292"/>
           <p:cNvSpPr txBox="1"/>
           <p:nvPr/>
         </p:nvSpPr>
@@ -12205,7 +12241,7 @@
       </p:sp>
       <p:sp>
         <p:nvSpPr>
-          <p:cNvPr id="9" name="card-292"/>
+          <p:cNvPr id="9" name="card-293"/>
           <p:cNvSpPr/>
           <p:nvPr/>
         </p:nvSpPr>
@@ -12239,7 +12275,7 @@
       </p:sp>
       <p:sp>
         <p:nvSpPr>
-          <p:cNvPr id="10" name="icon-bg-293"/>
+          <p:cNvPr id="10" name="icon-bg-294"/>
           <p:cNvSpPr/>
           <p:nvPr/>
         </p:nvSpPr>
@@ -12264,7 +12300,7 @@
       </p:sp>
       <p:pic>
         <p:nvPicPr>
-          <p:cNvPr id="11" name="icon-294" descr="preencoded.png">    </p:cNvPr>
+          <p:cNvPr id="11" name="icon-295" descr="preencoded.png">    </p:cNvPr>
           <p:cNvPicPr>
             <a:picLocks noChangeAspect="1"/>
           </p:cNvPicPr>
@@ -12288,7 +12324,7 @@
       </p:pic>
       <p:sp>
         <p:nvSpPr>
-          <p:cNvPr id="12" name="text-295"/>
+          <p:cNvPr id="12" name="text-296"/>
           <p:cNvSpPr txBox="1"/>
           <p:nvPr/>
         </p:nvSpPr>
@@ -12338,7 +12374,7 @@
       </p:sp>
       <p:sp>
         <p:nvSpPr>
-          <p:cNvPr id="13" name="text-296"/>
+          <p:cNvPr id="13" name="text-297"/>
           <p:cNvSpPr txBox="1"/>
           <p:nvPr/>
         </p:nvSpPr>
@@ -12929,7 +12965,7 @@
       </p:sp>
       <p:sp>
         <p:nvSpPr>
-          <p:cNvPr id="4" name="card-13"/>
+          <p:cNvPr id="4" name="card-14"/>
           <p:cNvSpPr/>
           <p:nvPr/>
         </p:nvSpPr>
@@ -12963,7 +12999,7 @@
       </p:sp>
       <p:sp>
         <p:nvSpPr>
-          <p:cNvPr id="5" name="icon-bg-14"/>
+          <p:cNvPr id="5" name="icon-bg-15"/>
           <p:cNvSpPr/>
           <p:nvPr/>
         </p:nvSpPr>
@@ -12988,7 +13024,7 @@
       </p:sp>
       <p:pic>
         <p:nvPicPr>
-          <p:cNvPr id="6" name="icon-15" descr="preencoded.png">    </p:cNvPr>
+          <p:cNvPr id="6" name="icon-16" descr="preencoded.png">    </p:cNvPr>
           <p:cNvPicPr>
             <a:picLocks noChangeAspect="1"/>
           </p:cNvPicPr>
@@ -13012,7 +13048,7 @@
       </p:pic>
       <p:sp>
         <p:nvSpPr>
-          <p:cNvPr id="7" name="text-16"/>
+          <p:cNvPr id="7" name="text-17"/>
           <p:cNvSpPr txBox="1"/>
           <p:nvPr/>
         </p:nvSpPr>
@@ -13048,7 +13084,7 @@
       </p:sp>
       <p:sp>
         <p:nvSpPr>
-          <p:cNvPr id="8" name="text-17"/>
+          <p:cNvPr id="8" name="text-18"/>
           <p:cNvSpPr txBox="1"/>
           <p:nvPr/>
         </p:nvSpPr>
@@ -13135,7 +13171,7 @@
       </p:sp>
       <p:sp>
         <p:nvSpPr>
-          <p:cNvPr id="9" name="card-18"/>
+          <p:cNvPr id="9" name="card-19"/>
           <p:cNvSpPr/>
           <p:nvPr/>
         </p:nvSpPr>
@@ -13169,7 +13205,7 @@
       </p:sp>
       <p:sp>
         <p:nvSpPr>
-          <p:cNvPr id="10" name="icon-bg-19"/>
+          <p:cNvPr id="10" name="icon-bg-20"/>
           <p:cNvSpPr/>
           <p:nvPr/>
         </p:nvSpPr>
@@ -13194,7 +13230,7 @@
       </p:sp>
       <p:pic>
         <p:nvPicPr>
-          <p:cNvPr id="11" name="icon-20" descr="preencoded.png">    </p:cNvPr>
+          <p:cNvPr id="11" name="icon-21" descr="preencoded.png">    </p:cNvPr>
           <p:cNvPicPr>
             <a:picLocks noChangeAspect="1"/>
           </p:cNvPicPr>
@@ -13218,7 +13254,7 @@
       </p:pic>
       <p:sp>
         <p:nvSpPr>
-          <p:cNvPr id="12" name="text-21"/>
+          <p:cNvPr id="12" name="text-22"/>
           <p:cNvSpPr txBox="1"/>
           <p:nvPr/>
         </p:nvSpPr>
@@ -13254,7 +13290,7 @@
       </p:sp>
       <p:sp>
         <p:nvSpPr>
-          <p:cNvPr id="13" name="text-22"/>
+          <p:cNvPr id="13" name="text-23"/>
           <p:cNvSpPr txBox="1"/>
           <p:nvPr/>
         </p:nvSpPr>
@@ -13341,7 +13377,7 @@
       </p:sp>
       <p:sp>
         <p:nvSpPr>
-          <p:cNvPr id="14" name="card-23"/>
+          <p:cNvPr id="14" name="card-24"/>
           <p:cNvSpPr/>
           <p:nvPr/>
         </p:nvSpPr>
@@ -13375,7 +13411,7 @@
       </p:sp>
       <p:sp>
         <p:nvSpPr>
-          <p:cNvPr id="15" name="icon-bg-24"/>
+          <p:cNvPr id="15" name="icon-bg-25"/>
           <p:cNvSpPr/>
           <p:nvPr/>
         </p:nvSpPr>
@@ -13400,7 +13436,7 @@
       </p:sp>
       <p:pic>
         <p:nvPicPr>
-          <p:cNvPr id="16" name="icon-25" descr="preencoded.png">    </p:cNvPr>
+          <p:cNvPr id="16" name="icon-26" descr="preencoded.png">    </p:cNvPr>
           <p:cNvPicPr>
             <a:picLocks noChangeAspect="1"/>
           </p:cNvPicPr>
@@ -13424,7 +13460,7 @@
       </p:pic>
       <p:sp>
         <p:nvSpPr>
-          <p:cNvPr id="17" name="text-26"/>
+          <p:cNvPr id="17" name="text-27"/>
           <p:cNvSpPr txBox="1"/>
           <p:nvPr/>
         </p:nvSpPr>
@@ -13460,7 +13496,7 @@
       </p:sp>
       <p:sp>
         <p:nvSpPr>
-          <p:cNvPr id="18" name="text-27"/>
+          <p:cNvPr id="18" name="text-28"/>
           <p:cNvSpPr txBox="1"/>
           <p:nvPr/>
         </p:nvSpPr>
@@ -13693,7 +13729,7 @@
       </p:sp>
       <p:sp>
         <p:nvSpPr>
-          <p:cNvPr id="4" name="card-297"/>
+          <p:cNvPr id="4" name="card-298"/>
           <p:cNvSpPr/>
           <p:nvPr/>
         </p:nvSpPr>
@@ -13727,7 +13763,7 @@
       </p:sp>
       <p:sp>
         <p:nvSpPr>
-          <p:cNvPr id="5" name="icon-bg-298"/>
+          <p:cNvPr id="5" name="icon-bg-299"/>
           <p:cNvSpPr/>
           <p:nvPr/>
         </p:nvSpPr>
@@ -13752,7 +13788,7 @@
       </p:sp>
       <p:pic>
         <p:nvPicPr>
-          <p:cNvPr id="6" name="icon-299" descr="preencoded.png">    </p:cNvPr>
+          <p:cNvPr id="6" name="icon-300" descr="preencoded.png">    </p:cNvPr>
           <p:cNvPicPr>
             <a:picLocks noChangeAspect="1"/>
           </p:cNvPicPr>
@@ -13776,7 +13812,7 @@
       </p:pic>
       <p:sp>
         <p:nvSpPr>
-          <p:cNvPr id="7" name="text-300"/>
+          <p:cNvPr id="7" name="text-301"/>
           <p:cNvSpPr txBox="1"/>
           <p:nvPr/>
         </p:nvSpPr>
@@ -13863,7 +13899,7 @@
       </p:sp>
       <p:sp>
         <p:nvSpPr>
-          <p:cNvPr id="8" name="card-301"/>
+          <p:cNvPr id="8" name="card-302"/>
           <p:cNvSpPr/>
           <p:nvPr/>
         </p:nvSpPr>
@@ -13897,7 +13933,7 @@
       </p:sp>
       <p:sp>
         <p:nvSpPr>
-          <p:cNvPr id="9" name="icon-bg-302"/>
+          <p:cNvPr id="9" name="icon-bg-303"/>
           <p:cNvSpPr/>
           <p:nvPr/>
         </p:nvSpPr>
@@ -13922,7 +13958,7 @@
       </p:sp>
       <p:pic>
         <p:nvPicPr>
-          <p:cNvPr id="10" name="icon-303" descr="preencoded.png">    </p:cNvPr>
+          <p:cNvPr id="10" name="icon-304" descr="preencoded.png">    </p:cNvPr>
           <p:cNvPicPr>
             <a:picLocks noChangeAspect="1"/>
           </p:cNvPicPr>
@@ -13946,7 +13982,7 @@
       </p:pic>
       <p:sp>
         <p:nvSpPr>
-          <p:cNvPr id="11" name="text-304"/>
+          <p:cNvPr id="11" name="text-305"/>
           <p:cNvSpPr txBox="1"/>
           <p:nvPr/>
         </p:nvSpPr>
@@ -14033,7 +14069,7 @@
       </p:sp>
       <p:sp>
         <p:nvSpPr>
-          <p:cNvPr id="12" name="card-305"/>
+          <p:cNvPr id="12" name="card-306"/>
           <p:cNvSpPr/>
           <p:nvPr/>
         </p:nvSpPr>
@@ -14067,7 +14103,7 @@
       </p:sp>
       <p:sp>
         <p:nvSpPr>
-          <p:cNvPr id="13" name="icon-bg-306"/>
+          <p:cNvPr id="13" name="icon-bg-307"/>
           <p:cNvSpPr/>
           <p:nvPr/>
         </p:nvSpPr>
@@ -14092,7 +14128,7 @@
       </p:sp>
       <p:pic>
         <p:nvPicPr>
-          <p:cNvPr id="14" name="icon-307" descr="preencoded.png">    </p:cNvPr>
+          <p:cNvPr id="14" name="icon-308" descr="preencoded.png">    </p:cNvPr>
           <p:cNvPicPr>
             <a:picLocks noChangeAspect="1"/>
           </p:cNvPicPr>
@@ -14116,7 +14152,7 @@
       </p:pic>
       <p:sp>
         <p:nvSpPr>
-          <p:cNvPr id="15" name="text-308"/>
+          <p:cNvPr id="15" name="text-309"/>
           <p:cNvSpPr txBox="1"/>
           <p:nvPr/>
         </p:nvSpPr>
@@ -14203,7 +14239,7 @@
       </p:sp>
       <p:sp>
         <p:nvSpPr>
-          <p:cNvPr id="16" name="card-309"/>
+          <p:cNvPr id="16" name="card-310"/>
           <p:cNvSpPr/>
           <p:nvPr/>
         </p:nvSpPr>
@@ -14237,7 +14273,7 @@
       </p:sp>
       <p:sp>
         <p:nvSpPr>
-          <p:cNvPr id="17" name="icon-bg-310"/>
+          <p:cNvPr id="17" name="icon-bg-311"/>
           <p:cNvSpPr/>
           <p:nvPr/>
         </p:nvSpPr>
@@ -14262,7 +14298,7 @@
       </p:sp>
       <p:pic>
         <p:nvPicPr>
-          <p:cNvPr id="18" name="icon-311" descr="preencoded.png">    </p:cNvPr>
+          <p:cNvPr id="18" name="icon-312" descr="preencoded.png">    </p:cNvPr>
           <p:cNvPicPr>
             <a:picLocks noChangeAspect="1"/>
           </p:cNvPicPr>
@@ -14286,7 +14322,7 @@
       </p:pic>
       <p:sp>
         <p:nvSpPr>
-          <p:cNvPr id="19" name="text-312"/>
+          <p:cNvPr id="19" name="text-313"/>
           <p:cNvSpPr txBox="1"/>
           <p:nvPr/>
         </p:nvSpPr>
@@ -14373,7 +14409,7 @@
       </p:sp>
       <p:sp>
         <p:nvSpPr>
-          <p:cNvPr id="20" name="card-313"/>
+          <p:cNvPr id="20" name="card-314"/>
           <p:cNvSpPr/>
           <p:nvPr/>
         </p:nvSpPr>
@@ -14407,7 +14443,7 @@
       </p:sp>
       <p:sp>
         <p:nvSpPr>
-          <p:cNvPr id="21" name="icon-bg-314"/>
+          <p:cNvPr id="21" name="icon-bg-315"/>
           <p:cNvSpPr/>
           <p:nvPr/>
         </p:nvSpPr>
@@ -14432,7 +14468,7 @@
       </p:sp>
       <p:pic>
         <p:nvPicPr>
-          <p:cNvPr id="22" name="icon-315" descr="preencoded.png">    </p:cNvPr>
+          <p:cNvPr id="22" name="icon-316" descr="preencoded.png">    </p:cNvPr>
           <p:cNvPicPr>
             <a:picLocks noChangeAspect="1"/>
           </p:cNvPicPr>
@@ -14456,7 +14492,7 @@
       </p:pic>
       <p:sp>
         <p:nvSpPr>
-          <p:cNvPr id="23" name="text-316"/>
+          <p:cNvPr id="23" name="text-317"/>
           <p:cNvSpPr txBox="1"/>
           <p:nvPr/>
         </p:nvSpPr>
@@ -14689,7 +14725,7 @@
       </p:sp>
       <p:sp>
         <p:nvSpPr>
-          <p:cNvPr id="4" name="card-317"/>
+          <p:cNvPr id="4" name="card-318"/>
           <p:cNvSpPr/>
           <p:nvPr/>
         </p:nvSpPr>
@@ -14723,7 +14759,7 @@
       </p:sp>
       <p:sp>
         <p:nvSpPr>
-          <p:cNvPr id="5" name="icon-bg-318"/>
+          <p:cNvPr id="5" name="icon-bg-319"/>
           <p:cNvSpPr/>
           <p:nvPr/>
         </p:nvSpPr>
@@ -14748,7 +14784,7 @@
       </p:sp>
       <p:pic>
         <p:nvPicPr>
-          <p:cNvPr id="6" name="icon-319" descr="preencoded.png">    </p:cNvPr>
+          <p:cNvPr id="6" name="icon-320" descr="preencoded.png">    </p:cNvPr>
           <p:cNvPicPr>
             <a:picLocks noChangeAspect="1"/>
           </p:cNvPicPr>
@@ -14772,7 +14808,7 @@
       </p:pic>
       <p:sp>
         <p:nvSpPr>
-          <p:cNvPr id="7" name="text-320"/>
+          <p:cNvPr id="7" name="text-321"/>
           <p:cNvSpPr txBox="1"/>
           <p:nvPr/>
         </p:nvSpPr>
@@ -14822,7 +14858,7 @@
       </p:sp>
       <p:sp>
         <p:nvSpPr>
-          <p:cNvPr id="8" name="text-321"/>
+          <p:cNvPr id="8" name="text-322"/>
           <p:cNvSpPr txBox="1"/>
           <p:nvPr/>
         </p:nvSpPr>
@@ -14972,7 +15008,7 @@
       </p:sp>
       <p:sp>
         <p:nvSpPr>
-          <p:cNvPr id="9" name="card-322"/>
+          <p:cNvPr id="9" name="card-323"/>
           <p:cNvSpPr/>
           <p:nvPr/>
         </p:nvSpPr>
@@ -15006,7 +15042,7 @@
       </p:sp>
       <p:sp>
         <p:nvSpPr>
-          <p:cNvPr id="10" name="icon-bg-323"/>
+          <p:cNvPr id="10" name="icon-bg-324"/>
           <p:cNvSpPr/>
           <p:nvPr/>
         </p:nvSpPr>
@@ -15031,7 +15067,7 @@
       </p:sp>
       <p:pic>
         <p:nvPicPr>
-          <p:cNvPr id="11" name="icon-324" descr="preencoded.png">    </p:cNvPr>
+          <p:cNvPr id="11" name="icon-325" descr="preencoded.png">    </p:cNvPr>
           <p:cNvPicPr>
             <a:picLocks noChangeAspect="1"/>
           </p:cNvPicPr>
@@ -15055,7 +15091,7 @@
       </p:pic>
       <p:sp>
         <p:nvSpPr>
-          <p:cNvPr id="12" name="text-325"/>
+          <p:cNvPr id="12" name="text-326"/>
           <p:cNvSpPr txBox="1"/>
           <p:nvPr/>
         </p:nvSpPr>
@@ -15105,7 +15141,7 @@
       </p:sp>
       <p:sp>
         <p:nvSpPr>
-          <p:cNvPr id="13" name="text-326"/>
+          <p:cNvPr id="13" name="text-327"/>
           <p:cNvSpPr txBox="1"/>
           <p:nvPr/>
         </p:nvSpPr>
@@ -15255,7 +15291,7 @@
       </p:sp>
       <p:sp>
         <p:nvSpPr>
-          <p:cNvPr id="14" name="card-327"/>
+          <p:cNvPr id="14" name="card-328"/>
           <p:cNvSpPr/>
           <p:nvPr/>
         </p:nvSpPr>
@@ -15289,7 +15325,7 @@
       </p:sp>
       <p:sp>
         <p:nvSpPr>
-          <p:cNvPr id="15" name="text-328"/>
+          <p:cNvPr id="15" name="text-329"/>
           <p:cNvSpPr txBox="1"/>
           <p:nvPr/>
         </p:nvSpPr>
@@ -15353,7 +15389,7 @@
       </p:sp>
       <p:sp>
         <p:nvSpPr>
-          <p:cNvPr id="16" name="card-329"/>
+          <p:cNvPr id="16" name="card-330"/>
           <p:cNvSpPr/>
           <p:nvPr/>
         </p:nvSpPr>
@@ -15387,7 +15423,7 @@
       </p:sp>
       <p:sp>
         <p:nvSpPr>
-          <p:cNvPr id="17" name="text-330"/>
+          <p:cNvPr id="17" name="text-331"/>
           <p:cNvSpPr txBox="1"/>
           <p:nvPr/>
         </p:nvSpPr>
@@ -15597,7 +15633,7 @@
       </p:sp>
       <p:sp>
         <p:nvSpPr>
-          <p:cNvPr id="4" name="text-331"/>
+          <p:cNvPr id="4" name="text-332"/>
           <p:cNvSpPr txBox="1"/>
           <p:nvPr/>
         </p:nvSpPr>
@@ -15633,7 +15669,7 @@
       </p:sp>
       <p:sp>
         <p:nvSpPr>
-          <p:cNvPr id="5" name="text-332"/>
+          <p:cNvPr id="5" name="text-333"/>
           <p:cNvSpPr txBox="1"/>
           <p:nvPr/>
         </p:nvSpPr>
@@ -15669,7 +15705,7 @@
       </p:sp>
       <p:sp>
         <p:nvSpPr>
-          <p:cNvPr id="6" name="text-333"/>
+          <p:cNvPr id="6" name="text-334"/>
           <p:cNvSpPr txBox="1"/>
           <p:nvPr/>
         </p:nvSpPr>
@@ -15719,7 +15755,7 @@
       </p:sp>
       <p:sp>
         <p:nvSpPr>
-          <p:cNvPr id="7" name="text-334"/>
+          <p:cNvPr id="7" name="text-335"/>
           <p:cNvSpPr txBox="1"/>
           <p:nvPr/>
         </p:nvSpPr>
@@ -15769,7 +15805,7 @@
       </p:sp>
       <p:sp>
         <p:nvSpPr>
-          <p:cNvPr id="8" name="quad-335"/>
+          <p:cNvPr id="8" name="quad-336"/>
           <p:cNvSpPr/>
           <p:nvPr/>
         </p:nvSpPr>
@@ -15803,7 +15839,7 @@
       </p:sp>
       <p:sp>
         <p:nvSpPr>
-          <p:cNvPr id="9" name="text-336"/>
+          <p:cNvPr id="9" name="text-337"/>
           <p:cNvSpPr txBox="1"/>
           <p:nvPr/>
         </p:nvSpPr>
@@ -15839,7 +15875,7 @@
       </p:sp>
       <p:sp>
         <p:nvSpPr>
-          <p:cNvPr id="10" name="text-337"/>
+          <p:cNvPr id="10" name="text-338"/>
           <p:cNvSpPr txBox="1"/>
           <p:nvPr/>
         </p:nvSpPr>
@@ -15875,7 +15911,7 @@
       </p:sp>
       <p:sp>
         <p:nvSpPr>
-          <p:cNvPr id="11" name="text-338"/>
+          <p:cNvPr id="11" name="text-339"/>
           <p:cNvSpPr txBox="1"/>
           <p:nvPr/>
         </p:nvSpPr>
@@ -15928,7 +15964,7 @@
       </p:sp>
       <p:sp>
         <p:nvSpPr>
-          <p:cNvPr id="12" name="quad-339"/>
+          <p:cNvPr id="12" name="quad-340"/>
           <p:cNvSpPr/>
           <p:nvPr/>
         </p:nvSpPr>
@@ -15962,7 +15998,7 @@
       </p:sp>
       <p:sp>
         <p:nvSpPr>
-          <p:cNvPr id="13" name="text-340"/>
+          <p:cNvPr id="13" name="text-341"/>
           <p:cNvSpPr txBox="1"/>
           <p:nvPr/>
         </p:nvSpPr>
@@ -15998,7 +16034,7 @@
       </p:sp>
       <p:sp>
         <p:nvSpPr>
-          <p:cNvPr id="14" name="text-341"/>
+          <p:cNvPr id="14" name="text-342"/>
           <p:cNvSpPr txBox="1"/>
           <p:nvPr/>
         </p:nvSpPr>
@@ -16034,7 +16070,7 @@
       </p:sp>
       <p:sp>
         <p:nvSpPr>
-          <p:cNvPr id="15" name="text-342"/>
+          <p:cNvPr id="15" name="text-343"/>
           <p:cNvSpPr txBox="1"/>
           <p:nvPr/>
         </p:nvSpPr>
@@ -16087,7 +16123,7 @@
       </p:sp>
       <p:sp>
         <p:nvSpPr>
-          <p:cNvPr id="16" name="quad-343"/>
+          <p:cNvPr id="16" name="quad-344"/>
           <p:cNvSpPr/>
           <p:nvPr/>
         </p:nvSpPr>
@@ -16121,7 +16157,7 @@
       </p:sp>
       <p:sp>
         <p:nvSpPr>
-          <p:cNvPr id="17" name="text-344"/>
+          <p:cNvPr id="17" name="text-345"/>
           <p:cNvSpPr txBox="1"/>
           <p:nvPr/>
         </p:nvSpPr>
@@ -16157,7 +16193,7 @@
       </p:sp>
       <p:sp>
         <p:nvSpPr>
-          <p:cNvPr id="18" name="text-345"/>
+          <p:cNvPr id="18" name="text-346"/>
           <p:cNvSpPr txBox="1"/>
           <p:nvPr/>
         </p:nvSpPr>
@@ -16193,7 +16229,7 @@
       </p:sp>
       <p:sp>
         <p:nvSpPr>
-          <p:cNvPr id="19" name="text-346"/>
+          <p:cNvPr id="19" name="text-347"/>
           <p:cNvSpPr txBox="1"/>
           <p:nvPr/>
         </p:nvSpPr>
@@ -16246,7 +16282,7 @@
       </p:sp>
       <p:sp>
         <p:nvSpPr>
-          <p:cNvPr id="20" name="quad-347"/>
+          <p:cNvPr id="20" name="quad-348"/>
           <p:cNvSpPr/>
           <p:nvPr/>
         </p:nvSpPr>
@@ -16280,7 +16316,7 @@
       </p:sp>
       <p:sp>
         <p:nvSpPr>
-          <p:cNvPr id="21" name="text-348"/>
+          <p:cNvPr id="21" name="text-349"/>
           <p:cNvSpPr txBox="1"/>
           <p:nvPr/>
         </p:nvSpPr>
@@ -16316,7 +16352,7 @@
       </p:sp>
       <p:sp>
         <p:nvSpPr>
-          <p:cNvPr id="22" name="text-349"/>
+          <p:cNvPr id="22" name="text-350"/>
           <p:cNvSpPr txBox="1"/>
           <p:nvPr/>
         </p:nvSpPr>
@@ -16352,7 +16388,7 @@
       </p:sp>
       <p:sp>
         <p:nvSpPr>
-          <p:cNvPr id="23" name="text-350"/>
+          <p:cNvPr id="23" name="text-351"/>
           <p:cNvSpPr txBox="1"/>
           <p:nvPr/>
         </p:nvSpPr>
@@ -16551,7 +16587,7 @@
       </p:sp>
       <p:sp>
         <p:nvSpPr>
-          <p:cNvPr id="4" name="dep-351"/>
+          <p:cNvPr id="4" name="dep-352"/>
           <p:cNvSpPr/>
           <p:nvPr/>
         </p:nvSpPr>
@@ -16578,7 +16614,7 @@
       </p:sp>
       <p:sp>
         <p:nvSpPr>
-          <p:cNvPr id="5" name="text-352"/>
+          <p:cNvPr id="5" name="text-353"/>
           <p:cNvSpPr txBox="1"/>
           <p:nvPr/>
         </p:nvSpPr>
@@ -16614,7 +16650,7 @@
       </p:sp>
       <p:sp>
         <p:nvSpPr>
-          <p:cNvPr id="6" name="icon-bg-353"/>
+          <p:cNvPr id="6" name="icon-bg-354"/>
           <p:cNvSpPr/>
           <p:nvPr/>
         </p:nvSpPr>
@@ -16639,7 +16675,7 @@
       </p:sp>
       <p:pic>
         <p:nvPicPr>
-          <p:cNvPr id="7" name="icon-354" descr="preencoded.png">    </p:cNvPr>
+          <p:cNvPr id="7" name="icon-355" descr="preencoded.png">    </p:cNvPr>
           <p:cNvPicPr>
             <a:picLocks noChangeAspect="1"/>
           </p:cNvPicPr>
@@ -16663,7 +16699,7 @@
       </p:pic>
       <p:sp>
         <p:nvSpPr>
-          <p:cNvPr id="8" name="text-355"/>
+          <p:cNvPr id="8" name="text-356"/>
           <p:cNvSpPr txBox="1"/>
           <p:nvPr/>
         </p:nvSpPr>
@@ -16750,7 +16786,7 @@
       </p:sp>
       <p:sp>
         <p:nvSpPr>
-          <p:cNvPr id="9" name="dep-356"/>
+          <p:cNvPr id="9" name="dep-357"/>
           <p:cNvSpPr/>
           <p:nvPr/>
         </p:nvSpPr>
@@ -16777,7 +16813,7 @@
       </p:sp>
       <p:sp>
         <p:nvSpPr>
-          <p:cNvPr id="10" name="text-357"/>
+          <p:cNvPr id="10" name="text-358"/>
           <p:cNvSpPr txBox="1"/>
           <p:nvPr/>
         </p:nvSpPr>
@@ -16813,7 +16849,7 @@
       </p:sp>
       <p:sp>
         <p:nvSpPr>
-          <p:cNvPr id="11" name="icon-bg-358"/>
+          <p:cNvPr id="11" name="icon-bg-359"/>
           <p:cNvSpPr/>
           <p:nvPr/>
         </p:nvSpPr>
@@ -16838,7 +16874,7 @@
       </p:sp>
       <p:pic>
         <p:nvPicPr>
-          <p:cNvPr id="12" name="icon-359" descr="preencoded.png">    </p:cNvPr>
+          <p:cNvPr id="12" name="icon-360" descr="preencoded.png">    </p:cNvPr>
           <p:cNvPicPr>
             <a:picLocks noChangeAspect="1"/>
           </p:cNvPicPr>
@@ -16862,7 +16898,7 @@
       </p:pic>
       <p:sp>
         <p:nvSpPr>
-          <p:cNvPr id="13" name="text-360"/>
+          <p:cNvPr id="13" name="text-361"/>
           <p:cNvSpPr txBox="1"/>
           <p:nvPr/>
         </p:nvSpPr>
@@ -16949,7 +16985,7 @@
       </p:sp>
       <p:sp>
         <p:nvSpPr>
-          <p:cNvPr id="14" name="dep-361"/>
+          <p:cNvPr id="14" name="dep-362"/>
           <p:cNvSpPr/>
           <p:nvPr/>
         </p:nvSpPr>
@@ -16976,7 +17012,7 @@
       </p:sp>
       <p:sp>
         <p:nvSpPr>
-          <p:cNvPr id="15" name="text-362"/>
+          <p:cNvPr id="15" name="text-363"/>
           <p:cNvSpPr txBox="1"/>
           <p:nvPr/>
         </p:nvSpPr>
@@ -17012,7 +17048,7 @@
       </p:sp>
       <p:sp>
         <p:nvSpPr>
-          <p:cNvPr id="16" name="icon-bg-363"/>
+          <p:cNvPr id="16" name="icon-bg-364"/>
           <p:cNvSpPr/>
           <p:nvPr/>
         </p:nvSpPr>
@@ -17037,7 +17073,7 @@
       </p:sp>
       <p:pic>
         <p:nvPicPr>
-          <p:cNvPr id="17" name="icon-364" descr="preencoded.png">    </p:cNvPr>
+          <p:cNvPr id="17" name="icon-365" descr="preencoded.png">    </p:cNvPr>
           <p:cNvPicPr>
             <a:picLocks noChangeAspect="1"/>
           </p:cNvPicPr>
@@ -17061,7 +17097,7 @@
       </p:pic>
       <p:sp>
         <p:nvSpPr>
-          <p:cNvPr id="18" name="text-365"/>
+          <p:cNvPr id="18" name="text-366"/>
           <p:cNvSpPr txBox="1"/>
           <p:nvPr/>
         </p:nvSpPr>
@@ -17148,7 +17184,7 @@
       </p:sp>
       <p:sp>
         <p:nvSpPr>
-          <p:cNvPr id="19" name="dep-366"/>
+          <p:cNvPr id="19" name="dep-367"/>
           <p:cNvSpPr/>
           <p:nvPr/>
         </p:nvSpPr>
@@ -17175,7 +17211,7 @@
       </p:sp>
       <p:sp>
         <p:nvSpPr>
-          <p:cNvPr id="20" name="text-367"/>
+          <p:cNvPr id="20" name="text-368"/>
           <p:cNvSpPr txBox="1"/>
           <p:nvPr/>
         </p:nvSpPr>
@@ -17211,7 +17247,7 @@
       </p:sp>
       <p:sp>
         <p:nvSpPr>
-          <p:cNvPr id="21" name="icon-bg-368"/>
+          <p:cNvPr id="21" name="icon-bg-369"/>
           <p:cNvSpPr/>
           <p:nvPr/>
         </p:nvSpPr>
@@ -17236,7 +17272,7 @@
       </p:sp>
       <p:pic>
         <p:nvPicPr>
-          <p:cNvPr id="22" name="icon-369" descr="preencoded.png">    </p:cNvPr>
+          <p:cNvPr id="22" name="icon-370" descr="preencoded.png">    </p:cNvPr>
           <p:cNvPicPr>
             <a:picLocks noChangeAspect="1"/>
           </p:cNvPicPr>
@@ -17260,7 +17296,7 @@
       </p:pic>
       <p:sp>
         <p:nvSpPr>
-          <p:cNvPr id="23" name="text-370"/>
+          <p:cNvPr id="23" name="text-371"/>
           <p:cNvSpPr txBox="1"/>
           <p:nvPr/>
         </p:nvSpPr>
@@ -17347,7 +17383,7 @@
       </p:sp>
       <p:sp>
         <p:nvSpPr>
-          <p:cNvPr id="24" name="dep-371"/>
+          <p:cNvPr id="24" name="dep-372"/>
           <p:cNvSpPr/>
           <p:nvPr/>
         </p:nvSpPr>
@@ -17374,7 +17410,7 @@
       </p:sp>
       <p:sp>
         <p:nvSpPr>
-          <p:cNvPr id="25" name="text-372"/>
+          <p:cNvPr id="25" name="text-373"/>
           <p:cNvSpPr txBox="1"/>
           <p:nvPr/>
         </p:nvSpPr>
@@ -17410,7 +17446,7 @@
       </p:sp>
       <p:sp>
         <p:nvSpPr>
-          <p:cNvPr id="26" name="icon-bg-373"/>
+          <p:cNvPr id="26" name="icon-bg-374"/>
           <p:cNvSpPr/>
           <p:nvPr/>
         </p:nvSpPr>
@@ -17435,7 +17471,7 @@
       </p:sp>
       <p:pic>
         <p:nvPicPr>
-          <p:cNvPr id="27" name="icon-374" descr="preencoded.png">    </p:cNvPr>
+          <p:cNvPr id="27" name="icon-375" descr="preencoded.png">    </p:cNvPr>
           <p:cNvPicPr>
             <a:picLocks noChangeAspect="1"/>
           </p:cNvPicPr>
@@ -17459,7 +17495,7 @@
       </p:pic>
       <p:sp>
         <p:nvSpPr>
-          <p:cNvPr id="28" name="text-375"/>
+          <p:cNvPr id="28" name="text-376"/>
           <p:cNvSpPr txBox="1"/>
           <p:nvPr/>
         </p:nvSpPr>
@@ -17546,7 +17582,7 @@
       </p:sp>
       <p:sp>
         <p:nvSpPr>
-          <p:cNvPr id="29" name="card-376"/>
+          <p:cNvPr id="29" name="card-377"/>
           <p:cNvSpPr/>
           <p:nvPr/>
         </p:nvSpPr>
@@ -17580,7 +17616,7 @@
       </p:sp>
       <p:sp>
         <p:nvSpPr>
-          <p:cNvPr id="30" name="icon-bg-377"/>
+          <p:cNvPr id="30" name="icon-bg-378"/>
           <p:cNvSpPr/>
           <p:nvPr/>
         </p:nvSpPr>
@@ -17605,7 +17641,7 @@
       </p:sp>
       <p:pic>
         <p:nvPicPr>
-          <p:cNvPr id="31" name="icon-378" descr="preencoded.png">    </p:cNvPr>
+          <p:cNvPr id="31" name="icon-379" descr="preencoded.png">    </p:cNvPr>
           <p:cNvPicPr>
             <a:picLocks noChangeAspect="1"/>
           </p:cNvPicPr>
@@ -17629,7 +17665,7 @@
       </p:pic>
       <p:sp>
         <p:nvSpPr>
-          <p:cNvPr id="32" name="text-379"/>
+          <p:cNvPr id="32" name="text-380"/>
           <p:cNvSpPr txBox="1"/>
           <p:nvPr/>
         </p:nvSpPr>
@@ -17679,7 +17715,7 @@
       </p:sp>
       <p:sp>
         <p:nvSpPr>
-          <p:cNvPr id="33" name="text-380"/>
+          <p:cNvPr id="33" name="text-381"/>
           <p:cNvSpPr txBox="1"/>
           <p:nvPr/>
         </p:nvSpPr>
@@ -17898,7 +17934,7 @@
       </p:sp>
       <p:sp>
         <p:nvSpPr>
-          <p:cNvPr id="5" name="tl-dot-381"/>
+          <p:cNvPr id="5" name="tl-dot-382"/>
           <p:cNvSpPr/>
           <p:nvPr/>
         </p:nvSpPr>
@@ -17923,7 +17959,7 @@
       </p:sp>
       <p:sp>
         <p:nvSpPr>
-          <p:cNvPr id="6" name="text-382"/>
+          <p:cNvPr id="6" name="text-383"/>
           <p:cNvSpPr txBox="1"/>
           <p:nvPr/>
         </p:nvSpPr>
@@ -17959,7 +17995,7 @@
       </p:sp>
       <p:sp>
         <p:nvSpPr>
-          <p:cNvPr id="7" name="tl-card-383"/>
+          <p:cNvPr id="7" name="tl-card-384"/>
           <p:cNvSpPr/>
           <p:nvPr/>
         </p:nvSpPr>
@@ -17993,7 +18029,7 @@
       </p:sp>
       <p:sp>
         <p:nvSpPr>
-          <p:cNvPr id="8" name="text-384"/>
+          <p:cNvPr id="8" name="text-385"/>
           <p:cNvSpPr txBox="1"/>
           <p:nvPr/>
         </p:nvSpPr>
@@ -18063,7 +18099,7 @@
       </p:sp>
       <p:sp>
         <p:nvSpPr>
-          <p:cNvPr id="9" name="tl-dot-385"/>
+          <p:cNvPr id="9" name="tl-dot-386"/>
           <p:cNvSpPr/>
           <p:nvPr/>
         </p:nvSpPr>
@@ -18088,7 +18124,7 @@
       </p:sp>
       <p:sp>
         <p:nvSpPr>
-          <p:cNvPr id="10" name="text-386"/>
+          <p:cNvPr id="10" name="text-387"/>
           <p:cNvSpPr txBox="1"/>
           <p:nvPr/>
         </p:nvSpPr>
@@ -18124,7 +18160,7 @@
       </p:sp>
       <p:sp>
         <p:nvSpPr>
-          <p:cNvPr id="11" name="tl-card-387"/>
+          <p:cNvPr id="11" name="tl-card-388"/>
           <p:cNvSpPr/>
           <p:nvPr/>
         </p:nvSpPr>
@@ -18158,7 +18194,7 @@
       </p:sp>
       <p:sp>
         <p:nvSpPr>
-          <p:cNvPr id="12" name="text-388"/>
+          <p:cNvPr id="12" name="text-389"/>
           <p:cNvSpPr txBox="1"/>
           <p:nvPr/>
         </p:nvSpPr>
@@ -18228,7 +18264,7 @@
       </p:sp>
       <p:sp>
         <p:nvSpPr>
-          <p:cNvPr id="13" name="tl-dot-389"/>
+          <p:cNvPr id="13" name="tl-dot-390"/>
           <p:cNvSpPr/>
           <p:nvPr/>
         </p:nvSpPr>
@@ -18253,7 +18289,7 @@
       </p:sp>
       <p:sp>
         <p:nvSpPr>
-          <p:cNvPr id="14" name="text-390"/>
+          <p:cNvPr id="14" name="text-391"/>
           <p:cNvSpPr txBox="1"/>
           <p:nvPr/>
         </p:nvSpPr>
@@ -18289,7 +18325,7 @@
       </p:sp>
       <p:sp>
         <p:nvSpPr>
-          <p:cNvPr id="15" name="tl-card-391"/>
+          <p:cNvPr id="15" name="tl-card-392"/>
           <p:cNvSpPr/>
           <p:nvPr/>
         </p:nvSpPr>
@@ -18323,7 +18359,7 @@
       </p:sp>
       <p:sp>
         <p:nvSpPr>
-          <p:cNvPr id="16" name="text-392"/>
+          <p:cNvPr id="16" name="text-393"/>
           <p:cNvSpPr txBox="1"/>
           <p:nvPr/>
         </p:nvSpPr>
@@ -18393,7 +18429,7 @@
       </p:sp>
       <p:sp>
         <p:nvSpPr>
-          <p:cNvPr id="17" name="tl-dot-393"/>
+          <p:cNvPr id="17" name="tl-dot-394"/>
           <p:cNvSpPr/>
           <p:nvPr/>
         </p:nvSpPr>
@@ -18418,7 +18454,7 @@
       </p:sp>
       <p:sp>
         <p:nvSpPr>
-          <p:cNvPr id="18" name="text-394"/>
+          <p:cNvPr id="18" name="text-395"/>
           <p:cNvSpPr txBox="1"/>
           <p:nvPr/>
         </p:nvSpPr>
@@ -18454,7 +18490,7 @@
       </p:sp>
       <p:sp>
         <p:nvSpPr>
-          <p:cNvPr id="19" name="tl-card-395"/>
+          <p:cNvPr id="19" name="tl-card-396"/>
           <p:cNvSpPr/>
           <p:nvPr/>
         </p:nvSpPr>
@@ -18488,7 +18524,7 @@
       </p:sp>
       <p:sp>
         <p:nvSpPr>
-          <p:cNvPr id="20" name="text-396"/>
+          <p:cNvPr id="20" name="text-397"/>
           <p:cNvSpPr txBox="1"/>
           <p:nvPr/>
         </p:nvSpPr>
@@ -18558,7 +18594,7 @@
       </p:sp>
       <p:sp>
         <p:nvSpPr>
-          <p:cNvPr id="21" name="tl-dot-397"/>
+          <p:cNvPr id="21" name="tl-dot-398"/>
           <p:cNvSpPr/>
           <p:nvPr/>
         </p:nvSpPr>
@@ -18583,7 +18619,7 @@
       </p:sp>
       <p:sp>
         <p:nvSpPr>
-          <p:cNvPr id="22" name="text-398"/>
+          <p:cNvPr id="22" name="text-399"/>
           <p:cNvSpPr txBox="1"/>
           <p:nvPr/>
         </p:nvSpPr>
@@ -18619,7 +18655,7 @@
       </p:sp>
       <p:sp>
         <p:nvSpPr>
-          <p:cNvPr id="23" name="tl-card-399"/>
+          <p:cNvPr id="23" name="tl-card-400"/>
           <p:cNvSpPr/>
           <p:nvPr/>
         </p:nvSpPr>
@@ -18653,7 +18689,7 @@
       </p:sp>
       <p:sp>
         <p:nvSpPr>
-          <p:cNvPr id="24" name="text-400"/>
+          <p:cNvPr id="24" name="text-401"/>
           <p:cNvSpPr txBox="1"/>
           <p:nvPr/>
         </p:nvSpPr>
@@ -18723,7 +18759,7 @@
       </p:sp>
       <p:sp>
         <p:nvSpPr>
-          <p:cNvPr id="25" name="tl-dot-401"/>
+          <p:cNvPr id="25" name="tl-dot-402"/>
           <p:cNvSpPr/>
           <p:nvPr/>
         </p:nvSpPr>
@@ -18748,7 +18784,7 @@
       </p:sp>
       <p:sp>
         <p:nvSpPr>
-          <p:cNvPr id="26" name="text-402"/>
+          <p:cNvPr id="26" name="text-403"/>
           <p:cNvSpPr txBox="1"/>
           <p:nvPr/>
         </p:nvSpPr>
@@ -18784,7 +18820,7 @@
       </p:sp>
       <p:sp>
         <p:nvSpPr>
-          <p:cNvPr id="27" name="tl-card-403"/>
+          <p:cNvPr id="27" name="tl-card-404"/>
           <p:cNvSpPr/>
           <p:nvPr/>
         </p:nvSpPr>
@@ -18818,7 +18854,7 @@
       </p:sp>
       <p:sp>
         <p:nvSpPr>
-          <p:cNvPr id="28" name="text-404"/>
+          <p:cNvPr id="28" name="text-405"/>
           <p:cNvSpPr txBox="1"/>
           <p:nvPr/>
         </p:nvSpPr>
@@ -19034,7 +19070,7 @@
       </p:sp>
       <p:sp>
         <p:nvSpPr>
-          <p:cNvPr id="4" name="text-405"/>
+          <p:cNvPr id="4" name="text-406"/>
           <p:cNvSpPr txBox="1"/>
           <p:nvPr/>
         </p:nvSpPr>
@@ -19070,7 +19106,7 @@
       </p:sp>
       <p:sp>
         <p:nvSpPr>
-          <p:cNvPr id="5" name="text-406"/>
+          <p:cNvPr id="5" name="text-407"/>
           <p:cNvSpPr txBox="1"/>
           <p:nvPr/>
         </p:nvSpPr>
@@ -19106,7 +19142,7 @@
       </p:sp>
       <p:sp>
         <p:nvSpPr>
-          <p:cNvPr id="6" name="refl-407"/>
+          <p:cNvPr id="6" name="refl-408"/>
           <p:cNvSpPr/>
           <p:nvPr/>
         </p:nvSpPr>
@@ -19133,7 +19169,7 @@
       </p:sp>
       <p:sp>
         <p:nvSpPr>
-          <p:cNvPr id="7" name="text-408"/>
+          <p:cNvPr id="7" name="text-409"/>
           <p:cNvSpPr txBox="1"/>
           <p:nvPr/>
         </p:nvSpPr>
@@ -19169,7 +19205,7 @@
       </p:sp>
       <p:sp>
         <p:nvSpPr>
-          <p:cNvPr id="8" name="text-409"/>
+          <p:cNvPr id="8" name="text-410"/>
           <p:cNvSpPr txBox="1"/>
           <p:nvPr/>
         </p:nvSpPr>
@@ -19205,7 +19241,7 @@
       </p:sp>
       <p:sp>
         <p:nvSpPr>
-          <p:cNvPr id="9" name="loa-410"/>
+          <p:cNvPr id="9" name="loa-411"/>
           <p:cNvSpPr/>
           <p:nvPr/>
         </p:nvSpPr>
@@ -19230,7 +19266,7 @@
       </p:sp>
       <p:sp>
         <p:nvSpPr>
-          <p:cNvPr id="10" name="text-411"/>
+          <p:cNvPr id="10" name="text-412"/>
           <p:cNvSpPr txBox="1"/>
           <p:nvPr/>
         </p:nvSpPr>
@@ -19266,7 +19302,7 @@
       </p:sp>
       <p:sp>
         <p:nvSpPr>
-          <p:cNvPr id="11" name="loa-412"/>
+          <p:cNvPr id="11" name="loa-413"/>
           <p:cNvSpPr/>
           <p:nvPr/>
         </p:nvSpPr>
@@ -19291,7 +19327,7 @@
       </p:sp>
       <p:sp>
         <p:nvSpPr>
-          <p:cNvPr id="12" name="text-413"/>
+          <p:cNvPr id="12" name="text-414"/>
           <p:cNvSpPr txBox="1"/>
           <p:nvPr/>
         </p:nvSpPr>
@@ -19327,7 +19363,7 @@
       </p:sp>
       <p:sp>
         <p:nvSpPr>
-          <p:cNvPr id="13" name="loa-414"/>
+          <p:cNvPr id="13" name="loa-415"/>
           <p:cNvSpPr/>
           <p:nvPr/>
         </p:nvSpPr>
@@ -19352,7 +19388,7 @@
       </p:sp>
       <p:sp>
         <p:nvSpPr>
-          <p:cNvPr id="14" name="text-415"/>
+          <p:cNvPr id="14" name="text-416"/>
           <p:cNvSpPr txBox="1"/>
           <p:nvPr/>
         </p:nvSpPr>
@@ -19388,7 +19424,7 @@
       </p:sp>
       <p:sp>
         <p:nvSpPr>
-          <p:cNvPr id="15" name="refl-416"/>
+          <p:cNvPr id="15" name="refl-417"/>
           <p:cNvSpPr/>
           <p:nvPr/>
         </p:nvSpPr>
@@ -19415,7 +19451,7 @@
       </p:sp>
       <p:sp>
         <p:nvSpPr>
-          <p:cNvPr id="16" name="text-417"/>
+          <p:cNvPr id="16" name="text-418"/>
           <p:cNvSpPr txBox="1"/>
           <p:nvPr/>
         </p:nvSpPr>
@@ -19451,7 +19487,7 @@
       </p:sp>
       <p:sp>
         <p:nvSpPr>
-          <p:cNvPr id="17" name="text-418"/>
+          <p:cNvPr id="17" name="text-419"/>
           <p:cNvSpPr txBox="1"/>
           <p:nvPr/>
         </p:nvSpPr>
@@ -19487,7 +19523,7 @@
       </p:sp>
       <p:sp>
         <p:nvSpPr>
-          <p:cNvPr id="18" name="loa-419"/>
+          <p:cNvPr id="18" name="loa-420"/>
           <p:cNvSpPr/>
           <p:nvPr/>
         </p:nvSpPr>
@@ -19512,7 +19548,7 @@
       </p:sp>
       <p:sp>
         <p:nvSpPr>
-          <p:cNvPr id="19" name="text-420"/>
+          <p:cNvPr id="19" name="text-421"/>
           <p:cNvSpPr txBox="1"/>
           <p:nvPr/>
         </p:nvSpPr>
@@ -19548,7 +19584,7 @@
       </p:sp>
       <p:sp>
         <p:nvSpPr>
-          <p:cNvPr id="20" name="loa-421"/>
+          <p:cNvPr id="20" name="loa-422"/>
           <p:cNvSpPr/>
           <p:nvPr/>
         </p:nvSpPr>
@@ -19573,7 +19609,7 @@
       </p:sp>
       <p:sp>
         <p:nvSpPr>
-          <p:cNvPr id="21" name="text-422"/>
+          <p:cNvPr id="21" name="text-423"/>
           <p:cNvSpPr txBox="1"/>
           <p:nvPr/>
         </p:nvSpPr>
@@ -19609,7 +19645,7 @@
       </p:sp>
       <p:sp>
         <p:nvSpPr>
-          <p:cNvPr id="22" name="loa-423"/>
+          <p:cNvPr id="22" name="loa-424"/>
           <p:cNvSpPr/>
           <p:nvPr/>
         </p:nvSpPr>
@@ -19634,7 +19670,7 @@
       </p:sp>
       <p:sp>
         <p:nvSpPr>
-          <p:cNvPr id="23" name="text-424"/>
+          <p:cNvPr id="23" name="text-425"/>
           <p:cNvSpPr txBox="1"/>
           <p:nvPr/>
         </p:nvSpPr>
@@ -19670,7 +19706,7 @@
       </p:sp>
       <p:sp>
         <p:nvSpPr>
-          <p:cNvPr id="24" name="refl-425"/>
+          <p:cNvPr id="24" name="refl-426"/>
           <p:cNvSpPr/>
           <p:nvPr/>
         </p:nvSpPr>
@@ -19697,7 +19733,7 @@
       </p:sp>
       <p:sp>
         <p:nvSpPr>
-          <p:cNvPr id="25" name="text-426"/>
+          <p:cNvPr id="25" name="text-427"/>
           <p:cNvSpPr txBox="1"/>
           <p:nvPr/>
         </p:nvSpPr>
@@ -19733,7 +19769,7 @@
       </p:sp>
       <p:sp>
         <p:nvSpPr>
-          <p:cNvPr id="26" name="text-427"/>
+          <p:cNvPr id="26" name="text-428"/>
           <p:cNvSpPr txBox="1"/>
           <p:nvPr/>
         </p:nvSpPr>
@@ -19769,7 +19805,7 @@
       </p:sp>
       <p:sp>
         <p:nvSpPr>
-          <p:cNvPr id="27" name="loa-428"/>
+          <p:cNvPr id="27" name="loa-429"/>
           <p:cNvSpPr/>
           <p:nvPr/>
         </p:nvSpPr>
@@ -19794,7 +19830,7 @@
       </p:sp>
       <p:sp>
         <p:nvSpPr>
-          <p:cNvPr id="28" name="text-429"/>
+          <p:cNvPr id="28" name="text-430"/>
           <p:cNvSpPr txBox="1"/>
           <p:nvPr/>
         </p:nvSpPr>
@@ -19830,7 +19866,7 @@
       </p:sp>
       <p:sp>
         <p:nvSpPr>
-          <p:cNvPr id="29" name="loa-430"/>
+          <p:cNvPr id="29" name="loa-431"/>
           <p:cNvSpPr/>
           <p:nvPr/>
         </p:nvSpPr>
@@ -19855,7 +19891,7 @@
       </p:sp>
       <p:sp>
         <p:nvSpPr>
-          <p:cNvPr id="30" name="text-431"/>
+          <p:cNvPr id="30" name="text-432"/>
           <p:cNvSpPr txBox="1"/>
           <p:nvPr/>
         </p:nvSpPr>
@@ -19891,7 +19927,7 @@
       </p:sp>
       <p:sp>
         <p:nvSpPr>
-          <p:cNvPr id="31" name="loa-432"/>
+          <p:cNvPr id="31" name="loa-433"/>
           <p:cNvSpPr/>
           <p:nvPr/>
         </p:nvSpPr>
@@ -19916,7 +19952,7 @@
       </p:sp>
       <p:sp>
         <p:nvSpPr>
-          <p:cNvPr id="32" name="text-433"/>
+          <p:cNvPr id="32" name="text-434"/>
           <p:cNvSpPr txBox="1"/>
           <p:nvPr/>
         </p:nvSpPr>
@@ -19952,7 +19988,7 @@
       </p:sp>
       <p:sp>
         <p:nvSpPr>
-          <p:cNvPr id="33" name="refl-434"/>
+          <p:cNvPr id="33" name="refl-435"/>
           <p:cNvSpPr/>
           <p:nvPr/>
         </p:nvSpPr>
@@ -19979,7 +20015,7 @@
       </p:sp>
       <p:sp>
         <p:nvSpPr>
-          <p:cNvPr id="34" name="text-435"/>
+          <p:cNvPr id="34" name="text-436"/>
           <p:cNvSpPr txBox="1"/>
           <p:nvPr/>
         </p:nvSpPr>
@@ -20015,7 +20051,7 @@
       </p:sp>
       <p:sp>
         <p:nvSpPr>
-          <p:cNvPr id="35" name="text-436"/>
+          <p:cNvPr id="35" name="text-437"/>
           <p:cNvSpPr txBox="1"/>
           <p:nvPr/>
         </p:nvSpPr>
@@ -20051,7 +20087,7 @@
       </p:sp>
       <p:sp>
         <p:nvSpPr>
-          <p:cNvPr id="36" name="loa-437"/>
+          <p:cNvPr id="36" name="loa-438"/>
           <p:cNvSpPr/>
           <p:nvPr/>
         </p:nvSpPr>
@@ -20076,7 +20112,7 @@
       </p:sp>
       <p:sp>
         <p:nvSpPr>
-          <p:cNvPr id="37" name="text-438"/>
+          <p:cNvPr id="37" name="text-439"/>
           <p:cNvSpPr txBox="1"/>
           <p:nvPr/>
         </p:nvSpPr>
@@ -20112,7 +20148,7 @@
       </p:sp>
       <p:sp>
         <p:nvSpPr>
-          <p:cNvPr id="38" name="loa-439"/>
+          <p:cNvPr id="38" name="loa-440"/>
           <p:cNvSpPr/>
           <p:nvPr/>
         </p:nvSpPr>
@@ -20137,7 +20173,7 @@
       </p:sp>
       <p:sp>
         <p:nvSpPr>
-          <p:cNvPr id="39" name="text-440"/>
+          <p:cNvPr id="39" name="text-441"/>
           <p:cNvSpPr txBox="1"/>
           <p:nvPr/>
         </p:nvSpPr>
@@ -20173,7 +20209,7 @@
       </p:sp>
       <p:sp>
         <p:nvSpPr>
-          <p:cNvPr id="40" name="loa-441"/>
+          <p:cNvPr id="40" name="loa-442"/>
           <p:cNvSpPr/>
           <p:nvPr/>
         </p:nvSpPr>
@@ -20198,7 +20234,7 @@
       </p:sp>
       <p:sp>
         <p:nvSpPr>
-          <p:cNvPr id="41" name="text-442"/>
+          <p:cNvPr id="41" name="text-443"/>
           <p:cNvSpPr txBox="1"/>
           <p:nvPr/>
         </p:nvSpPr>
@@ -20234,7 +20270,7 @@
       </p:sp>
       <p:sp>
         <p:nvSpPr>
-          <p:cNvPr id="42" name="refl-443"/>
+          <p:cNvPr id="42" name="refl-444"/>
           <p:cNvSpPr/>
           <p:nvPr/>
         </p:nvSpPr>
@@ -20261,7 +20297,7 @@
       </p:sp>
       <p:sp>
         <p:nvSpPr>
-          <p:cNvPr id="43" name="text-444"/>
+          <p:cNvPr id="43" name="text-445"/>
           <p:cNvSpPr txBox="1"/>
           <p:nvPr/>
         </p:nvSpPr>
@@ -20297,7 +20333,7 @@
       </p:sp>
       <p:sp>
         <p:nvSpPr>
-          <p:cNvPr id="44" name="text-445"/>
+          <p:cNvPr id="44" name="text-446"/>
           <p:cNvSpPr txBox="1"/>
           <p:nvPr/>
         </p:nvSpPr>
@@ -20333,7 +20369,7 @@
       </p:sp>
       <p:sp>
         <p:nvSpPr>
-          <p:cNvPr id="45" name="loa-446"/>
+          <p:cNvPr id="45" name="loa-447"/>
           <p:cNvSpPr/>
           <p:nvPr/>
         </p:nvSpPr>
@@ -20358,7 +20394,7 @@
       </p:sp>
       <p:sp>
         <p:nvSpPr>
-          <p:cNvPr id="46" name="text-447"/>
+          <p:cNvPr id="46" name="text-448"/>
           <p:cNvSpPr txBox="1"/>
           <p:nvPr/>
         </p:nvSpPr>
@@ -20394,7 +20430,7 @@
       </p:sp>
       <p:sp>
         <p:nvSpPr>
-          <p:cNvPr id="47" name="loa-448"/>
+          <p:cNvPr id="47" name="loa-449"/>
           <p:cNvSpPr/>
           <p:nvPr/>
         </p:nvSpPr>
@@ -20419,7 +20455,7 @@
       </p:sp>
       <p:sp>
         <p:nvSpPr>
-          <p:cNvPr id="48" name="text-449"/>
+          <p:cNvPr id="48" name="text-450"/>
           <p:cNvSpPr txBox="1"/>
           <p:nvPr/>
         </p:nvSpPr>
@@ -20455,7 +20491,7 @@
       </p:sp>
       <p:sp>
         <p:nvSpPr>
-          <p:cNvPr id="49" name="loa-450"/>
+          <p:cNvPr id="49" name="loa-451"/>
           <p:cNvSpPr/>
           <p:nvPr/>
         </p:nvSpPr>
@@ -20480,7 +20516,7 @@
       </p:sp>
       <p:sp>
         <p:nvSpPr>
-          <p:cNvPr id="50" name="text-451"/>
+          <p:cNvPr id="50" name="text-452"/>
           <p:cNvSpPr txBox="1"/>
           <p:nvPr/>
         </p:nvSpPr>
@@ -20662,7 +20698,7 @@
       </p:sp>
       <p:sp>
         <p:nvSpPr>
-          <p:cNvPr id="4" name="card-452"/>
+          <p:cNvPr id="4" name="card-453"/>
           <p:cNvSpPr/>
           <p:nvPr/>
         </p:nvSpPr>
@@ -20696,7 +20732,7 @@
       </p:sp>
       <p:sp>
         <p:nvSpPr>
-          <p:cNvPr id="5" name="icon-bg-453"/>
+          <p:cNvPr id="5" name="icon-bg-454"/>
           <p:cNvSpPr/>
           <p:nvPr/>
         </p:nvSpPr>
@@ -20721,7 +20757,7 @@
       </p:sp>
       <p:pic>
         <p:nvPicPr>
-          <p:cNvPr id="6" name="icon-454" descr="preencoded.png">    </p:cNvPr>
+          <p:cNvPr id="6" name="icon-455" descr="preencoded.png">    </p:cNvPr>
           <p:cNvPicPr>
             <a:picLocks noChangeAspect="1"/>
           </p:cNvPicPr>
@@ -20745,7 +20781,7 @@
       </p:pic>
       <p:sp>
         <p:nvSpPr>
-          <p:cNvPr id="7" name="text-455"/>
+          <p:cNvPr id="7" name="text-456"/>
           <p:cNvSpPr txBox="1"/>
           <p:nvPr/>
         </p:nvSpPr>
@@ -20832,7 +20868,7 @@
       </p:sp>
       <p:sp>
         <p:nvSpPr>
-          <p:cNvPr id="8" name="card-456"/>
+          <p:cNvPr id="8" name="card-457"/>
           <p:cNvSpPr/>
           <p:nvPr/>
         </p:nvSpPr>
@@ -20866,7 +20902,7 @@
       </p:sp>
       <p:sp>
         <p:nvSpPr>
-          <p:cNvPr id="9" name="icon-bg-457"/>
+          <p:cNvPr id="9" name="icon-bg-458"/>
           <p:cNvSpPr/>
           <p:nvPr/>
         </p:nvSpPr>
@@ -20891,7 +20927,7 @@
       </p:sp>
       <p:pic>
         <p:nvPicPr>
-          <p:cNvPr id="10" name="icon-458" descr="preencoded.png">    </p:cNvPr>
+          <p:cNvPr id="10" name="icon-459" descr="preencoded.png">    </p:cNvPr>
           <p:cNvPicPr>
             <a:picLocks noChangeAspect="1"/>
           </p:cNvPicPr>
@@ -20915,7 +20951,7 @@
       </p:pic>
       <p:sp>
         <p:nvSpPr>
-          <p:cNvPr id="11" name="text-459"/>
+          <p:cNvPr id="11" name="text-460"/>
           <p:cNvSpPr txBox="1"/>
           <p:nvPr/>
         </p:nvSpPr>
@@ -21002,7 +21038,7 @@
       </p:sp>
       <p:sp>
         <p:nvSpPr>
-          <p:cNvPr id="12" name="card-460"/>
+          <p:cNvPr id="12" name="card-461"/>
           <p:cNvSpPr/>
           <p:nvPr/>
         </p:nvSpPr>
@@ -21036,7 +21072,7 @@
       </p:sp>
       <p:sp>
         <p:nvSpPr>
-          <p:cNvPr id="13" name="icon-bg-461"/>
+          <p:cNvPr id="13" name="icon-bg-462"/>
           <p:cNvSpPr/>
           <p:nvPr/>
         </p:nvSpPr>
@@ -21061,7 +21097,7 @@
       </p:sp>
       <p:pic>
         <p:nvPicPr>
-          <p:cNvPr id="14" name="icon-462" descr="preencoded.png">    </p:cNvPr>
+          <p:cNvPr id="14" name="icon-463" descr="preencoded.png">    </p:cNvPr>
           <p:cNvPicPr>
             <a:picLocks noChangeAspect="1"/>
           </p:cNvPicPr>
@@ -21085,7 +21121,7 @@
       </p:pic>
       <p:sp>
         <p:nvSpPr>
-          <p:cNvPr id="15" name="text-463"/>
+          <p:cNvPr id="15" name="text-464"/>
           <p:cNvSpPr txBox="1"/>
           <p:nvPr/>
         </p:nvSpPr>
@@ -21172,7 +21208,7 @@
       </p:sp>
       <p:sp>
         <p:nvSpPr>
-          <p:cNvPr id="16" name="card-464"/>
+          <p:cNvPr id="16" name="card-465"/>
           <p:cNvSpPr/>
           <p:nvPr/>
         </p:nvSpPr>
@@ -21206,7 +21242,7 @@
       </p:sp>
       <p:sp>
         <p:nvSpPr>
-          <p:cNvPr id="17" name="text-465"/>
+          <p:cNvPr id="17" name="text-466"/>
           <p:cNvSpPr txBox="1"/>
           <p:nvPr/>
         </p:nvSpPr>
@@ -21242,7 +21278,7 @@
       </p:sp>
       <p:sp>
         <p:nvSpPr>
-          <p:cNvPr id="18" name="text-466"/>
+          <p:cNvPr id="18" name="text-467"/>
           <p:cNvSpPr txBox="1"/>
           <p:nvPr/>
         </p:nvSpPr>
@@ -21397,7 +21433,7 @@
       </p:pic>
       <p:sp>
         <p:nvSpPr>
-          <p:cNvPr id="4" name="text-467"/>
+          <p:cNvPr id="4" name="text-468"/>
           <p:cNvSpPr txBox="1"/>
           <p:nvPr/>
         </p:nvSpPr>
@@ -21433,7 +21469,7 @@
       </p:sp>
       <p:sp>
         <p:nvSpPr>
-          <p:cNvPr id="5" name="text-468"/>
+          <p:cNvPr id="5" name="text-469"/>
           <p:cNvSpPr txBox="1"/>
           <p:nvPr/>
         </p:nvSpPr>
@@ -21469,7 +21505,7 @@
       </p:sp>
       <p:sp>
         <p:nvSpPr>
-          <p:cNvPr id="6" name="text-469"/>
+          <p:cNvPr id="6" name="text-470"/>
           <p:cNvSpPr txBox="1"/>
           <p:nvPr/>
         </p:nvSpPr>
@@ -21505,7 +21541,43 @@
       </p:sp>
       <p:sp>
         <p:nvSpPr>
-          <p:cNvPr id="7" name="text-470"/>
+          <p:cNvPr id="7" name="text-471"/>
+          <p:cNvSpPr txBox="1"/>
+          <p:nvPr/>
+        </p:nvSpPr>
+        <p:spPr>
+          <a:xfrm>
+            <a:off x="640080" y="3611880"/>
+            <a:ext cx="5760720" cy="411480"/>
+          </a:xfrm>
+          <a:prstGeom prst="rect">
+            <a:avLst/>
+          </a:prstGeom>
+          <a:noFill/>
+          <a:ln/>
+        </p:spPr>
+        <p:txBody>
+          <a:bodyPr wrap="square" lIns="0" tIns="0" rIns="0" bIns="0" rtlCol="0" anchor="t"/>
+          <a:lstStyle/>
+          <a:p>
+            <a:pPr indent="0" marL="0">
+              <a:buNone/>
+            </a:pPr>
+            <a:r>
+              <a:rPr lang="en-US" sz="1800" b="1" dirty="0">
+                <a:solidFill>
+                  <a:schemeClr val="bg1"/>
+                </a:solidFill>
+              </a:rPr>
+              <a:t>by Mohamed Salah</a:t>
+            </a:r>
+            <a:endParaRPr lang="en-US" sz="1800" dirty="0"/>
+          </a:p>
+        </p:txBody>
+      </p:sp>
+      <p:sp>
+        <p:nvSpPr>
+          <p:cNvPr id="8" name="text-472"/>
           <p:cNvSpPr txBox="1"/>
           <p:nvPr/>
         </p:nvSpPr>
@@ -21717,7 +21789,7 @@
       </p:sp>
       <p:sp>
         <p:nvSpPr>
-          <p:cNvPr id="4" name="card-28"/>
+          <p:cNvPr id="4" name="card-29"/>
           <p:cNvSpPr/>
           <p:nvPr/>
         </p:nvSpPr>
@@ -21775,7 +21847,7 @@
       </p:pic>
       <p:sp>
         <p:nvSpPr>
-          <p:cNvPr id="6" name="text-29"/>
+          <p:cNvPr id="6" name="text-30"/>
           <p:cNvSpPr txBox="1"/>
           <p:nvPr/>
         </p:nvSpPr>
@@ -21845,7 +21917,7 @@
       </p:sp>
       <p:sp>
         <p:nvSpPr>
-          <p:cNvPr id="7" name="card-30"/>
+          <p:cNvPr id="7" name="card-31"/>
           <p:cNvSpPr/>
           <p:nvPr/>
         </p:nvSpPr>
@@ -21879,7 +21951,7 @@
       </p:sp>
       <p:sp>
         <p:nvSpPr>
-          <p:cNvPr id="8" name="icon-bg-31"/>
+          <p:cNvPr id="8" name="icon-bg-32"/>
           <p:cNvSpPr/>
           <p:nvPr/>
         </p:nvSpPr>
@@ -21904,7 +21976,7 @@
       </p:sp>
       <p:pic>
         <p:nvPicPr>
-          <p:cNvPr id="9" name="icon-32" descr="preencoded.png">    </p:cNvPr>
+          <p:cNvPr id="9" name="icon-33" descr="preencoded.png">    </p:cNvPr>
           <p:cNvPicPr>
             <a:picLocks noChangeAspect="1"/>
           </p:cNvPicPr>
@@ -21928,7 +22000,7 @@
       </p:pic>
       <p:sp>
         <p:nvSpPr>
-          <p:cNvPr id="10" name="text-33"/>
+          <p:cNvPr id="10" name="text-34"/>
           <p:cNvSpPr txBox="1"/>
           <p:nvPr/>
         </p:nvSpPr>
@@ -22015,7 +22087,7 @@
       </p:sp>
       <p:sp>
         <p:nvSpPr>
-          <p:cNvPr id="11" name="card-34"/>
+          <p:cNvPr id="11" name="card-35"/>
           <p:cNvSpPr/>
           <p:nvPr/>
         </p:nvSpPr>
@@ -22049,7 +22121,7 @@
       </p:sp>
       <p:sp>
         <p:nvSpPr>
-          <p:cNvPr id="12" name="icon-bg-35"/>
+          <p:cNvPr id="12" name="icon-bg-36"/>
           <p:cNvSpPr/>
           <p:nvPr/>
         </p:nvSpPr>
@@ -22074,7 +22146,7 @@
       </p:sp>
       <p:pic>
         <p:nvPicPr>
-          <p:cNvPr id="13" name="icon-36" descr="preencoded.png">    </p:cNvPr>
+          <p:cNvPr id="13" name="icon-37" descr="preencoded.png">    </p:cNvPr>
           <p:cNvPicPr>
             <a:picLocks noChangeAspect="1"/>
           </p:cNvPicPr>
@@ -22098,7 +22170,7 @@
       </p:pic>
       <p:sp>
         <p:nvSpPr>
-          <p:cNvPr id="14" name="text-37"/>
+          <p:cNvPr id="14" name="text-38"/>
           <p:cNvSpPr txBox="1"/>
           <p:nvPr/>
         </p:nvSpPr>
@@ -22185,7 +22257,7 @@
       </p:sp>
       <p:sp>
         <p:nvSpPr>
-          <p:cNvPr id="15" name="card-38"/>
+          <p:cNvPr id="15" name="card-39"/>
           <p:cNvSpPr/>
           <p:nvPr/>
         </p:nvSpPr>
@@ -22219,7 +22291,7 @@
       </p:sp>
       <p:sp>
         <p:nvSpPr>
-          <p:cNvPr id="16" name="icon-bg-39"/>
+          <p:cNvPr id="16" name="icon-bg-40"/>
           <p:cNvSpPr/>
           <p:nvPr/>
         </p:nvSpPr>
@@ -22244,7 +22316,7 @@
       </p:sp>
       <p:pic>
         <p:nvPicPr>
-          <p:cNvPr id="17" name="icon-40" descr="preencoded.png">    </p:cNvPr>
+          <p:cNvPr id="17" name="icon-41" descr="preencoded.png">    </p:cNvPr>
           <p:cNvPicPr>
             <a:picLocks noChangeAspect="1"/>
           </p:cNvPicPr>
@@ -22268,7 +22340,7 @@
       </p:pic>
       <p:sp>
         <p:nvSpPr>
-          <p:cNvPr id="18" name="text-41"/>
+          <p:cNvPr id="18" name="text-42"/>
           <p:cNvSpPr txBox="1"/>
           <p:nvPr/>
         </p:nvSpPr>
@@ -22355,7 +22427,7 @@
       </p:sp>
       <p:sp>
         <p:nvSpPr>
-          <p:cNvPr id="19" name="card-42"/>
+          <p:cNvPr id="19" name="card-43"/>
           <p:cNvSpPr/>
           <p:nvPr/>
         </p:nvSpPr>
@@ -22389,7 +22461,7 @@
       </p:sp>
       <p:sp>
         <p:nvSpPr>
-          <p:cNvPr id="20" name="icon-bg-43"/>
+          <p:cNvPr id="20" name="icon-bg-44"/>
           <p:cNvSpPr/>
           <p:nvPr/>
         </p:nvSpPr>
@@ -22414,7 +22486,7 @@
       </p:sp>
       <p:pic>
         <p:nvPicPr>
-          <p:cNvPr id="21" name="icon-44" descr="preencoded.png">    </p:cNvPr>
+          <p:cNvPr id="21" name="icon-45" descr="preencoded.png">    </p:cNvPr>
           <p:cNvPicPr>
             <a:picLocks noChangeAspect="1"/>
           </p:cNvPicPr>
@@ -22438,7 +22510,7 @@
       </p:pic>
       <p:sp>
         <p:nvSpPr>
-          <p:cNvPr id="22" name="text-45"/>
+          <p:cNvPr id="22" name="text-46"/>
           <p:cNvSpPr txBox="1"/>
           <p:nvPr/>
         </p:nvSpPr>
@@ -22966,7 +23038,7 @@
       </p:sp>
       <p:sp>
         <p:nvSpPr>
-          <p:cNvPr id="4" name="text-46"/>
+          <p:cNvPr id="4" name="text-47"/>
           <p:cNvSpPr txBox="1"/>
           <p:nvPr/>
         </p:nvSpPr>
@@ -23002,7 +23074,7 @@
       </p:sp>
       <p:sp>
         <p:nvSpPr>
-          <p:cNvPr id="5" name="text-47"/>
+          <p:cNvPr id="5" name="text-48"/>
           <p:cNvSpPr txBox="1"/>
           <p:nvPr/>
         </p:nvSpPr>
@@ -23038,7 +23110,7 @@
       </p:sp>
       <p:sp>
         <p:nvSpPr>
-          <p:cNvPr id="6" name="from-48"/>
+          <p:cNvPr id="6" name="from-49"/>
           <p:cNvSpPr/>
           <p:nvPr/>
         </p:nvSpPr>
@@ -23065,7 +23137,7 @@
       </p:sp>
       <p:sp>
         <p:nvSpPr>
-          <p:cNvPr id="7" name="text-49"/>
+          <p:cNvPr id="7" name="text-50"/>
           <p:cNvSpPr txBox="1"/>
           <p:nvPr/>
         </p:nvSpPr>
@@ -23115,7 +23187,7 @@
       </p:sp>
       <p:pic>
         <p:nvPicPr>
-          <p:cNvPr id="8" name="arrow-50" descr="preencoded.png">    </p:cNvPr>
+          <p:cNvPr id="8" name="arrow-51" descr="preencoded.png">    </p:cNvPr>
           <p:cNvPicPr>
             <a:picLocks noChangeAspect="1"/>
           </p:cNvPicPr>
@@ -23139,7 +23211,7 @@
       </p:pic>
       <p:sp>
         <p:nvSpPr>
-          <p:cNvPr id="9" name="to-51"/>
+          <p:cNvPr id="9" name="to-52"/>
           <p:cNvSpPr/>
           <p:nvPr/>
         </p:nvSpPr>
@@ -23166,7 +23238,7 @@
       </p:sp>
       <p:sp>
         <p:nvSpPr>
-          <p:cNvPr id="10" name="text-52"/>
+          <p:cNvPr id="10" name="text-53"/>
           <p:cNvSpPr txBox="1"/>
           <p:nvPr/>
         </p:nvSpPr>
@@ -23216,7 +23288,7 @@
       </p:sp>
       <p:sp>
         <p:nvSpPr>
-          <p:cNvPr id="11" name="from-53"/>
+          <p:cNvPr id="11" name="from-54"/>
           <p:cNvSpPr/>
           <p:nvPr/>
         </p:nvSpPr>
@@ -23243,7 +23315,7 @@
       </p:sp>
       <p:sp>
         <p:nvSpPr>
-          <p:cNvPr id="12" name="text-54"/>
+          <p:cNvPr id="12" name="text-55"/>
           <p:cNvSpPr txBox="1"/>
           <p:nvPr/>
         </p:nvSpPr>
@@ -23293,7 +23365,7 @@
       </p:sp>
       <p:pic>
         <p:nvPicPr>
-          <p:cNvPr id="13" name="arrow-55" descr="preencoded.png">    </p:cNvPr>
+          <p:cNvPr id="13" name="arrow-56" descr="preencoded.png">    </p:cNvPr>
           <p:cNvPicPr>
             <a:picLocks noChangeAspect="1"/>
           </p:cNvPicPr>
@@ -23317,7 +23389,7 @@
       </p:pic>
       <p:sp>
         <p:nvSpPr>
-          <p:cNvPr id="14" name="to-56"/>
+          <p:cNvPr id="14" name="to-57"/>
           <p:cNvSpPr/>
           <p:nvPr/>
         </p:nvSpPr>
@@ -23344,7 +23416,7 @@
       </p:sp>
       <p:sp>
         <p:nvSpPr>
-          <p:cNvPr id="15" name="text-57"/>
+          <p:cNvPr id="15" name="text-58"/>
           <p:cNvSpPr txBox="1"/>
           <p:nvPr/>
         </p:nvSpPr>
@@ -23394,7 +23466,7 @@
       </p:sp>
       <p:sp>
         <p:nvSpPr>
-          <p:cNvPr id="16" name="from-58"/>
+          <p:cNvPr id="16" name="from-59"/>
           <p:cNvSpPr/>
           <p:nvPr/>
         </p:nvSpPr>
@@ -23421,7 +23493,7 @@
       </p:sp>
       <p:sp>
         <p:nvSpPr>
-          <p:cNvPr id="17" name="text-59"/>
+          <p:cNvPr id="17" name="text-60"/>
           <p:cNvSpPr txBox="1"/>
           <p:nvPr/>
         </p:nvSpPr>
@@ -23471,7 +23543,7 @@
       </p:sp>
       <p:pic>
         <p:nvPicPr>
-          <p:cNvPr id="18" name="arrow-60" descr="preencoded.png">    </p:cNvPr>
+          <p:cNvPr id="18" name="arrow-61" descr="preencoded.png">    </p:cNvPr>
           <p:cNvPicPr>
             <a:picLocks noChangeAspect="1"/>
           </p:cNvPicPr>
@@ -23495,7 +23567,7 @@
       </p:pic>
       <p:sp>
         <p:nvSpPr>
-          <p:cNvPr id="19" name="to-61"/>
+          <p:cNvPr id="19" name="to-62"/>
           <p:cNvSpPr/>
           <p:nvPr/>
         </p:nvSpPr>
@@ -23522,7 +23594,7 @@
       </p:sp>
       <p:sp>
         <p:nvSpPr>
-          <p:cNvPr id="20" name="text-62"/>
+          <p:cNvPr id="20" name="text-63"/>
           <p:cNvSpPr txBox="1"/>
           <p:nvPr/>
         </p:nvSpPr>
@@ -23572,7 +23644,7 @@
       </p:sp>
       <p:sp>
         <p:nvSpPr>
-          <p:cNvPr id="21" name="from-63"/>
+          <p:cNvPr id="21" name="from-64"/>
           <p:cNvSpPr/>
           <p:nvPr/>
         </p:nvSpPr>
@@ -23599,7 +23671,7 @@
       </p:sp>
       <p:sp>
         <p:nvSpPr>
-          <p:cNvPr id="22" name="text-64"/>
+          <p:cNvPr id="22" name="text-65"/>
           <p:cNvSpPr txBox="1"/>
           <p:nvPr/>
         </p:nvSpPr>
@@ -23649,7 +23721,7 @@
       </p:sp>
       <p:pic>
         <p:nvPicPr>
-          <p:cNvPr id="23" name="arrow-65" descr="preencoded.png">    </p:cNvPr>
+          <p:cNvPr id="23" name="arrow-66" descr="preencoded.png">    </p:cNvPr>
           <p:cNvPicPr>
             <a:picLocks noChangeAspect="1"/>
           </p:cNvPicPr>
@@ -23673,7 +23745,7 @@
       </p:pic>
       <p:sp>
         <p:nvSpPr>
-          <p:cNvPr id="24" name="to-66"/>
+          <p:cNvPr id="24" name="to-67"/>
           <p:cNvSpPr/>
           <p:nvPr/>
         </p:nvSpPr>
@@ -23700,7 +23772,7 @@
       </p:sp>
       <p:sp>
         <p:nvSpPr>
-          <p:cNvPr id="25" name="text-67"/>
+          <p:cNvPr id="25" name="text-68"/>
           <p:cNvSpPr txBox="1"/>
           <p:nvPr/>
         </p:nvSpPr>
@@ -23750,7 +23822,7 @@
       </p:sp>
       <p:sp>
         <p:nvSpPr>
-          <p:cNvPr id="26" name="from-68"/>
+          <p:cNvPr id="26" name="from-69"/>
           <p:cNvSpPr/>
           <p:nvPr/>
         </p:nvSpPr>
@@ -23777,7 +23849,7 @@
       </p:sp>
       <p:sp>
         <p:nvSpPr>
-          <p:cNvPr id="27" name="text-69"/>
+          <p:cNvPr id="27" name="text-70"/>
           <p:cNvSpPr txBox="1"/>
           <p:nvPr/>
         </p:nvSpPr>
@@ -23827,7 +23899,7 @@
       </p:sp>
       <p:pic>
         <p:nvPicPr>
-          <p:cNvPr id="28" name="arrow-70" descr="preencoded.png">    </p:cNvPr>
+          <p:cNvPr id="28" name="arrow-71" descr="preencoded.png">    </p:cNvPr>
           <p:cNvPicPr>
             <a:picLocks noChangeAspect="1"/>
           </p:cNvPicPr>
@@ -23851,7 +23923,7 @@
       </p:pic>
       <p:sp>
         <p:nvSpPr>
-          <p:cNvPr id="29" name="to-71"/>
+          <p:cNvPr id="29" name="to-72"/>
           <p:cNvSpPr/>
           <p:nvPr/>
         </p:nvSpPr>
@@ -23878,7 +23950,7 @@
       </p:sp>
       <p:sp>
         <p:nvSpPr>
-          <p:cNvPr id="30" name="text-72"/>
+          <p:cNvPr id="30" name="text-73"/>
           <p:cNvSpPr txBox="1"/>
           <p:nvPr/>
         </p:nvSpPr>
@@ -23928,7 +24000,7 @@
       </p:sp>
       <p:sp>
         <p:nvSpPr>
-          <p:cNvPr id="31" name="card-73"/>
+          <p:cNvPr id="31" name="card-74"/>
           <p:cNvSpPr/>
           <p:nvPr/>
         </p:nvSpPr>
@@ -23962,7 +24034,7 @@
       </p:sp>
       <p:sp>
         <p:nvSpPr>
-          <p:cNvPr id="32" name="text-74"/>
+          <p:cNvPr id="32" name="text-75"/>
           <p:cNvSpPr txBox="1"/>
           <p:nvPr/>
         </p:nvSpPr>
@@ -24178,7 +24250,7 @@
       </p:sp>
       <p:sp>
         <p:nvSpPr>
-          <p:cNvPr id="4" name="card-75"/>
+          <p:cNvPr id="4" name="card-76"/>
           <p:cNvSpPr/>
           <p:nvPr/>
         </p:nvSpPr>
@@ -24212,7 +24284,7 @@
       </p:sp>
       <p:sp>
         <p:nvSpPr>
-          <p:cNvPr id="5" name="icon-bg-76"/>
+          <p:cNvPr id="5" name="icon-bg-77"/>
           <p:cNvSpPr/>
           <p:nvPr/>
         </p:nvSpPr>
@@ -24237,7 +24309,7 @@
       </p:sp>
       <p:pic>
         <p:nvPicPr>
-          <p:cNvPr id="6" name="icon-77" descr="preencoded.png">    </p:cNvPr>
+          <p:cNvPr id="6" name="icon-78" descr="preencoded.png">    </p:cNvPr>
           <p:cNvPicPr>
             <a:picLocks noChangeAspect="1"/>
           </p:cNvPicPr>
@@ -24261,7 +24333,7 @@
       </p:pic>
       <p:sp>
         <p:nvSpPr>
-          <p:cNvPr id="7" name="text-78"/>
+          <p:cNvPr id="7" name="text-79"/>
           <p:cNvSpPr txBox="1"/>
           <p:nvPr/>
         </p:nvSpPr>
@@ -24297,7 +24369,7 @@
       </p:sp>
       <p:sp>
         <p:nvSpPr>
-          <p:cNvPr id="8" name="text-79"/>
+          <p:cNvPr id="8" name="text-80"/>
           <p:cNvSpPr txBox="1"/>
           <p:nvPr/>
         </p:nvSpPr>
@@ -24384,7 +24456,7 @@
       </p:sp>
       <p:sp>
         <p:nvSpPr>
-          <p:cNvPr id="9" name="card-80"/>
+          <p:cNvPr id="9" name="card-81"/>
           <p:cNvSpPr/>
           <p:nvPr/>
         </p:nvSpPr>
@@ -24418,7 +24490,7 @@
       </p:sp>
       <p:sp>
         <p:nvSpPr>
-          <p:cNvPr id="10" name="icon-bg-81"/>
+          <p:cNvPr id="10" name="icon-bg-82"/>
           <p:cNvSpPr/>
           <p:nvPr/>
         </p:nvSpPr>
@@ -24443,7 +24515,7 @@
       </p:sp>
       <p:pic>
         <p:nvPicPr>
-          <p:cNvPr id="11" name="icon-82" descr="preencoded.png">    </p:cNvPr>
+          <p:cNvPr id="11" name="icon-83" descr="preencoded.png">    </p:cNvPr>
           <p:cNvPicPr>
             <a:picLocks noChangeAspect="1"/>
           </p:cNvPicPr>
@@ -24467,7 +24539,7 @@
       </p:pic>
       <p:sp>
         <p:nvSpPr>
-          <p:cNvPr id="12" name="text-83"/>
+          <p:cNvPr id="12" name="text-84"/>
           <p:cNvSpPr txBox="1"/>
           <p:nvPr/>
         </p:nvSpPr>
@@ -24503,7 +24575,7 @@
       </p:sp>
       <p:sp>
         <p:nvSpPr>
-          <p:cNvPr id="13" name="text-84"/>
+          <p:cNvPr id="13" name="text-85"/>
           <p:cNvSpPr txBox="1"/>
           <p:nvPr/>
         </p:nvSpPr>
@@ -24590,7 +24662,7 @@
       </p:sp>
       <p:sp>
         <p:nvSpPr>
-          <p:cNvPr id="14" name="card-85"/>
+          <p:cNvPr id="14" name="card-86"/>
           <p:cNvSpPr/>
           <p:nvPr/>
         </p:nvSpPr>
@@ -24624,7 +24696,7 @@
       </p:sp>
       <p:sp>
         <p:nvSpPr>
-          <p:cNvPr id="15" name="icon-bg-86"/>
+          <p:cNvPr id="15" name="icon-bg-87"/>
           <p:cNvSpPr/>
           <p:nvPr/>
         </p:nvSpPr>
@@ -24649,7 +24721,7 @@
       </p:sp>
       <p:pic>
         <p:nvPicPr>
-          <p:cNvPr id="16" name="icon-87" descr="preencoded.png">    </p:cNvPr>
+          <p:cNvPr id="16" name="icon-88" descr="preencoded.png">    </p:cNvPr>
           <p:cNvPicPr>
             <a:picLocks noChangeAspect="1"/>
           </p:cNvPicPr>
@@ -24673,7 +24745,7 @@
       </p:pic>
       <p:sp>
         <p:nvSpPr>
-          <p:cNvPr id="17" name="text-88"/>
+          <p:cNvPr id="17" name="text-89"/>
           <p:cNvSpPr txBox="1"/>
           <p:nvPr/>
         </p:nvSpPr>
@@ -24709,7 +24781,7 @@
       </p:sp>
       <p:sp>
         <p:nvSpPr>
-          <p:cNvPr id="18" name="text-89"/>
+          <p:cNvPr id="18" name="text-90"/>
           <p:cNvSpPr txBox="1"/>
           <p:nvPr/>
         </p:nvSpPr>
@@ -24942,7 +25014,7 @@
       </p:sp>
       <p:sp>
         <p:nvSpPr>
-          <p:cNvPr id="4" name="card-90"/>
+          <p:cNvPr id="4" name="card-91"/>
           <p:cNvSpPr/>
           <p:nvPr/>
         </p:nvSpPr>
@@ -24976,7 +25048,7 @@
       </p:sp>
       <p:sp>
         <p:nvSpPr>
-          <p:cNvPr id="5" name="icon-bg-91"/>
+          <p:cNvPr id="5" name="icon-bg-92"/>
           <p:cNvSpPr/>
           <p:nvPr/>
         </p:nvSpPr>
@@ -25001,7 +25073,7 @@
       </p:sp>
       <p:pic>
         <p:nvPicPr>
-          <p:cNvPr id="6" name="icon-92" descr="preencoded.png">    </p:cNvPr>
+          <p:cNvPr id="6" name="icon-93" descr="preencoded.png">    </p:cNvPr>
           <p:cNvPicPr>
             <a:picLocks noChangeAspect="1"/>
           </p:cNvPicPr>
@@ -25025,7 +25097,7 @@
       </p:pic>
       <p:sp>
         <p:nvSpPr>
-          <p:cNvPr id="7" name="text-93"/>
+          <p:cNvPr id="7" name="text-94"/>
           <p:cNvSpPr txBox="1"/>
           <p:nvPr/>
         </p:nvSpPr>
@@ -25075,7 +25147,7 @@
       </p:sp>
       <p:sp>
         <p:nvSpPr>
-          <p:cNvPr id="8" name="text-94"/>
+          <p:cNvPr id="8" name="text-95"/>
           <p:cNvSpPr txBox="1"/>
           <p:nvPr/>
         </p:nvSpPr>
@@ -25232,7 +25304,7 @@
       </p:sp>
       <p:pic>
         <p:nvPicPr>
-          <p:cNvPr id="9" name="flow-arrow-95" descr="preencoded.png">    </p:cNvPr>
+          <p:cNvPr id="9" name="flow-arrow-96" descr="preencoded.png">    </p:cNvPr>
           <p:cNvPicPr>
             <a:picLocks noChangeAspect="1"/>
           </p:cNvPicPr>
@@ -25256,7 +25328,7 @@
       </p:pic>
       <p:sp>
         <p:nvSpPr>
-          <p:cNvPr id="10" name="card-96"/>
+          <p:cNvPr id="10" name="card-97"/>
           <p:cNvSpPr/>
           <p:nvPr/>
         </p:nvSpPr>
@@ -25290,7 +25362,7 @@
       </p:sp>
       <p:sp>
         <p:nvSpPr>
-          <p:cNvPr id="11" name="icon-bg-97"/>
+          <p:cNvPr id="11" name="icon-bg-98"/>
           <p:cNvSpPr/>
           <p:nvPr/>
         </p:nvSpPr>
@@ -25315,7 +25387,7 @@
       </p:sp>
       <p:pic>
         <p:nvPicPr>
-          <p:cNvPr id="12" name="icon-98" descr="preencoded.png">    </p:cNvPr>
+          <p:cNvPr id="12" name="icon-99" descr="preencoded.png">    </p:cNvPr>
           <p:cNvPicPr>
             <a:picLocks noChangeAspect="1"/>
           </p:cNvPicPr>
@@ -25339,7 +25411,7 @@
       </p:pic>
       <p:sp>
         <p:nvSpPr>
-          <p:cNvPr id="13" name="text-99"/>
+          <p:cNvPr id="13" name="text-100"/>
           <p:cNvSpPr txBox="1"/>
           <p:nvPr/>
         </p:nvSpPr>
@@ -25389,7 +25461,7 @@
       </p:sp>
       <p:sp>
         <p:nvSpPr>
-          <p:cNvPr id="14" name="text-100"/>
+          <p:cNvPr id="14" name="text-101"/>
           <p:cNvSpPr txBox="1"/>
           <p:nvPr/>
         </p:nvSpPr>
@@ -25546,7 +25618,7 @@
       </p:sp>
       <p:pic>
         <p:nvPicPr>
-          <p:cNvPr id="15" name="flow-arrow-101" descr="preencoded.png">    </p:cNvPr>
+          <p:cNvPr id="15" name="flow-arrow-102" descr="preencoded.png">    </p:cNvPr>
           <p:cNvPicPr>
             <a:picLocks noChangeAspect="1"/>
           </p:cNvPicPr>
@@ -25570,7 +25642,7 @@
       </p:pic>
       <p:sp>
         <p:nvSpPr>
-          <p:cNvPr id="16" name="card-102"/>
+          <p:cNvPr id="16" name="card-103"/>
           <p:cNvSpPr/>
           <p:nvPr/>
         </p:nvSpPr>
@@ -25604,7 +25676,7 @@
       </p:sp>
       <p:sp>
         <p:nvSpPr>
-          <p:cNvPr id="17" name="icon-bg-103"/>
+          <p:cNvPr id="17" name="icon-bg-104"/>
           <p:cNvSpPr/>
           <p:nvPr/>
         </p:nvSpPr>
@@ -25629,7 +25701,7 @@
       </p:sp>
       <p:pic>
         <p:nvPicPr>
-          <p:cNvPr id="18" name="icon-104" descr="preencoded.png">    </p:cNvPr>
+          <p:cNvPr id="18" name="icon-105" descr="preencoded.png">    </p:cNvPr>
           <p:cNvPicPr>
             <a:picLocks noChangeAspect="1"/>
           </p:cNvPicPr>
@@ -25653,7 +25725,7 @@
       </p:pic>
       <p:sp>
         <p:nvSpPr>
-          <p:cNvPr id="19" name="text-105"/>
+          <p:cNvPr id="19" name="text-106"/>
           <p:cNvSpPr txBox="1"/>
           <p:nvPr/>
         </p:nvSpPr>
@@ -25703,7 +25775,7 @@
       </p:sp>
       <p:sp>
         <p:nvSpPr>
-          <p:cNvPr id="20" name="text-106"/>
+          <p:cNvPr id="20" name="text-107"/>
           <p:cNvSpPr txBox="1"/>
           <p:nvPr/>
         </p:nvSpPr>
@@ -26006,7 +26078,7 @@
       </p:sp>
       <p:sp>
         <p:nvSpPr>
-          <p:cNvPr id="4" name="act-letter-107"/>
+          <p:cNvPr id="4" name="act-letter-108"/>
           <p:cNvSpPr/>
           <p:nvPr/>
         </p:nvSpPr>
@@ -26033,7 +26105,7 @@
       </p:sp>
       <p:sp>
         <p:nvSpPr>
-          <p:cNvPr id="5" name="text-108"/>
+          <p:cNvPr id="5" name="text-109"/>
           <p:cNvSpPr txBox="1"/>
           <p:nvPr/>
         </p:nvSpPr>
@@ -26069,7 +26141,7 @@
       </p:sp>
       <p:sp>
         <p:nvSpPr>
-          <p:cNvPr id="6" name="text-109"/>
+          <p:cNvPr id="6" name="text-110"/>
           <p:cNvSpPr txBox="1"/>
           <p:nvPr/>
         </p:nvSpPr>
@@ -26139,7 +26211,7 @@
       </p:sp>
       <p:sp>
         <p:nvSpPr>
-          <p:cNvPr id="7" name="act-letter-110"/>
+          <p:cNvPr id="7" name="act-letter-111"/>
           <p:cNvSpPr/>
           <p:nvPr/>
         </p:nvSpPr>
@@ -26166,7 +26238,7 @@
       </p:sp>
       <p:sp>
         <p:nvSpPr>
-          <p:cNvPr id="8" name="text-111"/>
+          <p:cNvPr id="8" name="text-112"/>
           <p:cNvSpPr txBox="1"/>
           <p:nvPr/>
         </p:nvSpPr>
@@ -26202,7 +26274,7 @@
       </p:sp>
       <p:sp>
         <p:nvSpPr>
-          <p:cNvPr id="9" name="text-112"/>
+          <p:cNvPr id="9" name="text-113"/>
           <p:cNvSpPr txBox="1"/>
           <p:nvPr/>
         </p:nvSpPr>
@@ -26272,7 +26344,7 @@
       </p:sp>
       <p:sp>
         <p:nvSpPr>
-          <p:cNvPr id="10" name="act-letter-113"/>
+          <p:cNvPr id="10" name="act-letter-114"/>
           <p:cNvSpPr/>
           <p:nvPr/>
         </p:nvSpPr>
@@ -26299,7 +26371,7 @@
       </p:sp>
       <p:sp>
         <p:nvSpPr>
-          <p:cNvPr id="11" name="text-114"/>
+          <p:cNvPr id="11" name="text-115"/>
           <p:cNvSpPr txBox="1"/>
           <p:nvPr/>
         </p:nvSpPr>
@@ -26335,7 +26407,7 @@
       </p:sp>
       <p:sp>
         <p:nvSpPr>
-          <p:cNvPr id="12" name="text-115"/>
+          <p:cNvPr id="12" name="text-116"/>
           <p:cNvSpPr txBox="1"/>
           <p:nvPr/>
         </p:nvSpPr>
@@ -26405,7 +26477,7 @@
       </p:sp>
       <p:sp>
         <p:nvSpPr>
-          <p:cNvPr id="13" name="text-116"/>
+          <p:cNvPr id="13" name="text-117"/>
           <p:cNvSpPr txBox="1"/>
           <p:nvPr/>
         </p:nvSpPr>
@@ -26441,7 +26513,7 @@
       </p:sp>
       <p:sp>
         <p:nvSpPr>
-          <p:cNvPr id="14" name="level-117"/>
+          <p:cNvPr id="14" name="level-118"/>
           <p:cNvSpPr/>
           <p:nvPr/>
         </p:nvSpPr>
@@ -26468,7 +26540,7 @@
       </p:sp>
       <p:sp>
         <p:nvSpPr>
-          <p:cNvPr id="15" name="text-118"/>
+          <p:cNvPr id="15" name="text-119"/>
           <p:cNvSpPr txBox="1"/>
           <p:nvPr/>
         </p:nvSpPr>
@@ -26504,7 +26576,7 @@
       </p:sp>
       <p:sp>
         <p:nvSpPr>
-          <p:cNvPr id="16" name="text-119"/>
+          <p:cNvPr id="16" name="text-120"/>
           <p:cNvSpPr txBox="1"/>
           <p:nvPr/>
         </p:nvSpPr>
@@ -26568,7 +26640,7 @@
       </p:sp>
       <p:sp>
         <p:nvSpPr>
-          <p:cNvPr id="17" name="level-120"/>
+          <p:cNvPr id="17" name="level-121"/>
           <p:cNvSpPr/>
           <p:nvPr/>
         </p:nvSpPr>
@@ -26595,7 +26667,7 @@
       </p:sp>
       <p:sp>
         <p:nvSpPr>
-          <p:cNvPr id="18" name="text-121"/>
+          <p:cNvPr id="18" name="text-122"/>
           <p:cNvSpPr txBox="1"/>
           <p:nvPr/>
         </p:nvSpPr>
@@ -26631,7 +26703,7 @@
       </p:sp>
       <p:sp>
         <p:nvSpPr>
-          <p:cNvPr id="19" name="text-122"/>
+          <p:cNvPr id="19" name="text-123"/>
           <p:cNvSpPr txBox="1"/>
           <p:nvPr/>
         </p:nvSpPr>
@@ -26695,7 +26767,7 @@
       </p:sp>
       <p:sp>
         <p:nvSpPr>
-          <p:cNvPr id="20" name="level-123"/>
+          <p:cNvPr id="20" name="level-124"/>
           <p:cNvSpPr/>
           <p:nvPr/>
         </p:nvSpPr>
@@ -26722,7 +26794,7 @@
       </p:sp>
       <p:sp>
         <p:nvSpPr>
-          <p:cNvPr id="21" name="text-124"/>
+          <p:cNvPr id="21" name="text-125"/>
           <p:cNvSpPr txBox="1"/>
           <p:nvPr/>
         </p:nvSpPr>
@@ -26758,7 +26830,7 @@
       </p:sp>
       <p:sp>
         <p:nvSpPr>
-          <p:cNvPr id="22" name="text-125"/>
+          <p:cNvPr id="22" name="text-126"/>
           <p:cNvSpPr txBox="1"/>
           <p:nvPr/>
         </p:nvSpPr>
@@ -26822,7 +26894,7 @@
       </p:sp>
       <p:sp>
         <p:nvSpPr>
-          <p:cNvPr id="23" name="level-126"/>
+          <p:cNvPr id="23" name="level-127"/>
           <p:cNvSpPr/>
           <p:nvPr/>
         </p:nvSpPr>
@@ -26849,7 +26921,7 @@
       </p:sp>
       <p:sp>
         <p:nvSpPr>
-          <p:cNvPr id="24" name="text-127"/>
+          <p:cNvPr id="24" name="text-128"/>
           <p:cNvSpPr txBox="1"/>
           <p:nvPr/>
         </p:nvSpPr>
@@ -26885,7 +26957,7 @@
       </p:sp>
       <p:sp>
         <p:nvSpPr>
-          <p:cNvPr id="25" name="text-128"/>
+          <p:cNvPr id="25" name="text-129"/>
           <p:cNvSpPr txBox="1"/>
           <p:nvPr/>
         </p:nvSpPr>
@@ -27095,7 +27167,7 @@
       </p:sp>
       <p:sp>
         <p:nvSpPr>
-          <p:cNvPr id="4" name="card-129"/>
+          <p:cNvPr id="4" name="card-130"/>
           <p:cNvSpPr/>
           <p:nvPr/>
         </p:nvSpPr>
@@ -27129,7 +27201,7 @@
       </p:sp>
       <p:sp>
         <p:nvSpPr>
-          <p:cNvPr id="5" name="icon-bg-130"/>
+          <p:cNvPr id="5" name="icon-bg-131"/>
           <p:cNvSpPr/>
           <p:nvPr/>
         </p:nvSpPr>
@@ -27154,7 +27226,7 @@
       </p:sp>
       <p:pic>
         <p:nvPicPr>
-          <p:cNvPr id="6" name="icon-131" descr="preencoded.png">    </p:cNvPr>
+          <p:cNvPr id="6" name="icon-132" descr="preencoded.png">    </p:cNvPr>
           <p:cNvPicPr>
             <a:picLocks noChangeAspect="1"/>
           </p:cNvPicPr>
@@ -27178,7 +27250,7 @@
       </p:pic>
       <p:sp>
         <p:nvSpPr>
-          <p:cNvPr id="7" name="text-132"/>
+          <p:cNvPr id="7" name="text-133"/>
           <p:cNvSpPr txBox="1"/>
           <p:nvPr/>
         </p:nvSpPr>
@@ -27265,7 +27337,7 @@
       </p:sp>
       <p:sp>
         <p:nvSpPr>
-          <p:cNvPr id="8" name="card-133"/>
+          <p:cNvPr id="8" name="card-134"/>
           <p:cNvSpPr/>
           <p:nvPr/>
         </p:nvSpPr>
@@ -27299,7 +27371,7 @@
       </p:sp>
       <p:sp>
         <p:nvSpPr>
-          <p:cNvPr id="9" name="icon-bg-134"/>
+          <p:cNvPr id="9" name="icon-bg-135"/>
           <p:cNvSpPr/>
           <p:nvPr/>
         </p:nvSpPr>
@@ -27324,7 +27396,7 @@
       </p:sp>
       <p:pic>
         <p:nvPicPr>
-          <p:cNvPr id="10" name="icon-135" descr="preencoded.png">    </p:cNvPr>
+          <p:cNvPr id="10" name="icon-136" descr="preencoded.png">    </p:cNvPr>
           <p:cNvPicPr>
             <a:picLocks noChangeAspect="1"/>
           </p:cNvPicPr>
@@ -27348,7 +27420,7 @@
       </p:pic>
       <p:sp>
         <p:nvSpPr>
-          <p:cNvPr id="11" name="text-136"/>
+          <p:cNvPr id="11" name="text-137"/>
           <p:cNvSpPr txBox="1"/>
           <p:nvPr/>
         </p:nvSpPr>
@@ -27435,7 +27507,7 @@
       </p:sp>
       <p:sp>
         <p:nvSpPr>
-          <p:cNvPr id="12" name="card-137"/>
+          <p:cNvPr id="12" name="card-138"/>
           <p:cNvSpPr/>
           <p:nvPr/>
         </p:nvSpPr>
@@ -27469,7 +27541,7 @@
       </p:sp>
       <p:sp>
         <p:nvSpPr>
-          <p:cNvPr id="13" name="icon-bg-138"/>
+          <p:cNvPr id="13" name="icon-bg-139"/>
           <p:cNvSpPr/>
           <p:nvPr/>
         </p:nvSpPr>
@@ -27494,7 +27566,7 @@
       </p:sp>
       <p:pic>
         <p:nvPicPr>
-          <p:cNvPr id="14" name="icon-139" descr="preencoded.png">    </p:cNvPr>
+          <p:cNvPr id="14" name="icon-140" descr="preencoded.png">    </p:cNvPr>
           <p:cNvPicPr>
             <a:picLocks noChangeAspect="1"/>
           </p:cNvPicPr>
@@ -27518,7 +27590,7 @@
       </p:pic>
       <p:sp>
         <p:nvSpPr>
-          <p:cNvPr id="15" name="text-140"/>
+          <p:cNvPr id="15" name="text-141"/>
           <p:cNvSpPr txBox="1"/>
           <p:nvPr/>
         </p:nvSpPr>
@@ -27605,7 +27677,7 @@
       </p:sp>
       <p:sp>
         <p:nvSpPr>
-          <p:cNvPr id="16" name="card-141"/>
+          <p:cNvPr id="16" name="card-142"/>
           <p:cNvSpPr/>
           <p:nvPr/>
         </p:nvSpPr>
@@ -27639,7 +27711,7 @@
       </p:sp>
       <p:sp>
         <p:nvSpPr>
-          <p:cNvPr id="17" name="icon-bg-142"/>
+          <p:cNvPr id="17" name="icon-bg-143"/>
           <p:cNvSpPr/>
           <p:nvPr/>
         </p:nvSpPr>
@@ -27664,7 +27736,7 @@
       </p:sp>
       <p:pic>
         <p:nvPicPr>
-          <p:cNvPr id="18" name="icon-143" descr="preencoded.png">    </p:cNvPr>
+          <p:cNvPr id="18" name="icon-144" descr="preencoded.png">    </p:cNvPr>
           <p:cNvPicPr>
             <a:picLocks noChangeAspect="1"/>
           </p:cNvPicPr>
@@ -27688,7 +27760,7 @@
       </p:pic>
       <p:sp>
         <p:nvSpPr>
-          <p:cNvPr id="19" name="text-144"/>
+          <p:cNvPr id="19" name="text-145"/>
           <p:cNvSpPr txBox="1"/>
           <p:nvPr/>
         </p:nvSpPr>

</xml_diff>